<commit_message>
Revise hackathon deck for Track 02 submission rules
Rebuild the nine-slide deck to cover all eight required points, scoring
weights, multi-agent critique loop, Zetaris/H-MEM/Nightshift/Nemotron
evidence, product visuals, and future work — timed ~3:15 per demo guide.

Co-authored-by: shrieraam1991-ops <shrieraam1991-ops@users.noreply.github.com>
</commit_message>
<xml_diff>
--- a/docs/hackathon-deck.pptx
+++ b/docs/hackathon-deck.pptx
@@ -515,7 +515,7 @@
           </a:p>
           <a:p>
             <a:r>
-              <a:t>A founder spent over fifteen thousand dollars building with an AI app-builder, and no tool told them what the app would cost to build or to run. AI features are priced per token, and the bill only shows up after you've built.</a:t>
+              <a:t>Name Track: The Agent That Can Explain Why. Problem + solo founders in one or two sentences. Mentally note scoring weights for judges; do not read the whole table aloud.</a:t>
             </a:r>
           </a:p>
         </p:txBody>
@@ -590,7 +590,7 @@
           </a:p>
           <a:p>
             <a:r>
-              <a:t>This is for solo founders. You describe your idea and 2–5 AI features. In about thirty seconds of reading the pack you see stage costs, margin, measured vs estimated tokens, checks, and a full trace. Anything we couldn't measure is labeled — never invented.</a:t>
+              <a:t>Input → process → output. Say sample vs live. Emphasize actionable DecisionPack and honest labels. No savings claims.</a:t>
             </a:r>
           </a:p>
         </p:txBody>
@@ -660,12 +660,12 @@
           <a:lstStyle/>
           <a:p>
             <a:r>
-              <a:t>0:40–1:00 (~20s)</a:t>
-            </a:r>
-          </a:p>
-          <a:p>
-            <a:r>
-              <a:t>Six steps: memory recall, Zetaris prices, Nightshift candidates, capped measured runs, checks plus Critic flags, then stage projection and evidence write-back. Unknown stays labeled.</a:t>
+              <a:t>0:40–1:05 (~25s)</a:t>
+            </a:r>
+          </a:p>
+          <a:p>
+            <a:r>
+              <a:t>At least two agents collaborating with critique/repair — show the loop. Name H-MEM. Name Lightning/Ultra via Nightshift.</a:t>
             </a:r>
           </a:p>
         </p:txBody>
@@ -735,12 +735,12 @@
           <a:lstStyle/>
           <a:p>
             <a:r>
-              <a:t>1:00–1:15 (~15s)</a:t>
-            </a:r>
-          </a:p>
-          <a:p>
-            <a:r>
-              <a:t>Demo walkthrough: open Streamlit, pick an example (e.g. example_3 writing assistant). Features and growth stages are editable assumptions. Prices will come from the Zetaris snapshot shown in the sidebar when live.</a:t>
+              <a:t>1:05–1:15 (~10s)</a:t>
+            </a:r>
+          </a:p>
+          <a:p>
+            <a:r>
+              <a:t>Quick stack pass. Point to public repo and sample mode.</a:t>
             </a:r>
           </a:p>
         </p:txBody>
@@ -810,12 +810,12 @@
           <a:lstStyle/>
           <a:p>
             <a:r>
-              <a:t>1:15–1:45 (~30s)</a:t>
-            </a:r>
-          </a:p>
-          <a:p>
-            <a:r>
-              <a:t>Nothing that costs money runs without approval and a cap. Progress: H-MEM recall → Zetaris query → Nightshift routes → candidates → Planner on Nemotron Lightning → measured model requests → Critic on Nemotron Ultra. Cap: thirty attempts; spend reserved before each call.</a:t>
+              <a:t>1:15–1:40 (~25s)</a:t>
+            </a:r>
+          </a:p>
+          <a:p>
+            <a:r>
+              <a:t>Must-show: Zetaris query, H-MEM engine feature + test, one Nightshift request with model name, Nemotron where we claim NVIDIA.</a:t>
             </a:r>
           </a:p>
         </p:txBody>
@@ -885,12 +885,12 @@
           <a:lstStyle/>
           <a:p>
             <a:r>
-              <a:t>1:45–2:05 (~20s)</a:t>
-            </a:r>
-          </a:p>
-          <a:p>
-            <a:r>
-              <a:t>Same tools that run the agent produce the evidence. Zetaris for prices and write-back. Nightshift for every call. H-MEM for memory. Nemotron Lightning plans; Ultra critiques — flags only, never grades.</a:t>
+              <a:t>1:40–1:55 (~15s)</a:t>
+            </a:r>
+          </a:p>
+          <a:p>
+            <a:r>
+              <a:t>One concrete unique behaviour from SPONSOR_PARAGRAPH. Optional DEMO_SCRIPT 10s insert.</a:t>
             </a:r>
           </a:p>
         </p:txBody>
@@ -960,12 +960,12 @@
           <a:lstStyle/>
           <a:p>
             <a:r>
-              <a:t>2:05–2:35 (~30s)</a:t>
-            </a:r>
-          </a:p>
-          <a:p>
-            <a:r>
-              <a:t>The founder answer: monthly AI cost from fifty users to fifty thousand, with revenue and AI margin. Switch cheapest-per-feature vs one model for all. Totals only include what was priced; unknowns are lower bounds — never hidden as zero. We never claim dollar savings.</a:t>
+              <a:t>1:55–2:15 (~20s)</a:t>
+            </a:r>
+          </a:p>
+          <a:p>
+            <a:r>
+              <a:t>Show Brief and Run. Live or recorded real/synthetic run. Mention approval/cap.</a:t>
             </a:r>
           </a:p>
         </p:txBody>
@@ -1035,12 +1035,12 @@
           <a:lstStyle/>
           <a:p>
             <a:r>
-              <a:t>2:35–2:55 (~20s)</a:t>
-            </a:r>
-          </a:p>
-          <a:p>
-            <a:r>
-              <a:t>Why measuring matters: estimates beside real usage. Projected-only stays labeled. Quality is rules plus human review; the Critic only flags. Trace is the proof for Track 02 — the agent that can explain why.</a:t>
+              <a:t>2:15–2:45 (~30s)</a:t>
+            </a:r>
+          </a:p>
+          <a:p>
+            <a:r>
+              <a:t>Final output + why it matters. Measured vs estimated. Trace proves collaboration. No savings claim.</a:t>
             </a:r>
           </a:p>
         </p:txBody>
@@ -1110,12 +1110,12 @@
           <a:lstStyle/>
           <a:p>
             <a:r>
-              <a:t>2:55–3:15 (~20s)</a:t>
-            </a:r>
-          </a:p>
-          <a:p>
-            <a:r>
-              <a:t>AI SaaS Cost Advisor: know what your AI will cost before you build. Sponsors for data, routing, memory, and Nemotron planning/critique. Try it offline in sample mode. Thank you.</a:t>
+              <a:t>2:45–3:15 (~30s)</a:t>
+            </a:r>
+          </a:p>
+          <a:p>
+            <a:r>
+              <a:t>Future short and clearly unbuilt. Close with sponsors + repo + sample mode. Stop by 3:15–3:30.</a:t>
             </a:r>
           </a:p>
         </p:txBody>
@@ -4215,8 +4215,8 @@
         </p:nvSpPr>
         <p:spPr>
           <a:xfrm>
-            <a:off x="640080" y="457200"/>
-            <a:ext cx="10058400" cy="365760"/>
+            <a:off x="640080" y="365760"/>
+            <a:ext cx="10972800" cy="320040"/>
           </a:xfrm>
           <a:prstGeom prst="rect">
             <a:avLst/>
@@ -4231,7 +4231,7 @@
           <a:p>
             <a:pPr algn="l">
               <a:spcAft>
-                <a:spcPts val="600"/>
+                <a:spcPts val="500"/>
               </a:spcAft>
               <a:defRPr sz="1400" b="1">
                 <a:solidFill>
@@ -4241,7 +4241,7 @@
               </a:defRPr>
             </a:pPr>
             <a:r>
-              <a:t>Open Agent Hackathon 2026 · Track 02: The Agent That Can Explain Why</a:t>
+              <a:t>Open Agent Hackathon 2026 · Track: The Agent That Can Explain Why</a:t>
             </a:r>
           </a:p>
         </p:txBody>
@@ -4254,8 +4254,8 @@
         </p:nvSpPr>
         <p:spPr>
           <a:xfrm>
-            <a:off x="640080" y="1828800"/>
-            <a:ext cx="10515600" cy="1280160"/>
+            <a:off x="640080" y="1051560"/>
+            <a:ext cx="10972800" cy="822960"/>
           </a:xfrm>
           <a:prstGeom prst="rect">
             <a:avLst/>
@@ -4270,9 +4270,9 @@
           <a:p>
             <a:pPr algn="l">
               <a:spcAft>
-                <a:spcPts val="600"/>
+                <a:spcPts val="500"/>
               </a:spcAft>
-              <a:defRPr sz="4800" b="1">
+              <a:defRPr sz="4200" b="1">
                 <a:solidFill>
                   <a:srgbClr val="0A0A0A"/>
                 </a:solidFill>
@@ -4293,8 +4293,8 @@
         </p:nvSpPr>
         <p:spPr>
           <a:xfrm>
-            <a:off x="640080" y="3200400"/>
-            <a:ext cx="10058400" cy="1097280"/>
+            <a:off x="640080" y="2011680"/>
+            <a:ext cx="10972800" cy="1188720"/>
           </a:xfrm>
           <a:prstGeom prst="rect">
             <a:avLst/>
@@ -4309,9 +4309,9 @@
           <a:p>
             <a:pPr algn="l">
               <a:spcAft>
-                <a:spcPts val="600"/>
+                <a:spcPts val="500"/>
               </a:spcAft>
-              <a:defRPr sz="2400" b="0">
+              <a:defRPr sz="2000" b="0">
                 <a:solidFill>
                   <a:srgbClr val="3A3A3A"/>
                 </a:solidFill>
@@ -4319,15 +4319,15 @@
               </a:defRPr>
             </a:pPr>
             <a:r>
-              <a:t>Over $15,000 spent building with an AI app-builder.</a:t>
+              <a:t>Problem: A founder spent over $15,000 building with an AI app-builder,</a:t>
             </a:r>
           </a:p>
           <a:p>
             <a:pPr algn="l">
               <a:spcAft>
-                <a:spcPts val="600"/>
+                <a:spcPts val="500"/>
               </a:spcAft>
-              <a:defRPr sz="2400" b="0">
+              <a:defRPr sz="2000" b="0">
                 <a:solidFill>
                   <a:srgbClr val="3A3A3A"/>
                 </a:solidFill>
@@ -4335,7 +4335,7 @@
               </a:defRPr>
             </a:pPr>
             <a:r>
-              <a:t>No tool estimated what the app would cost to build — or to run.</a:t>
+              <a:t>and no tool estimated what the app would cost to build or to run.</a:t>
             </a:r>
           </a:p>
         </p:txBody>
@@ -4348,8 +4348,8 @@
         </p:nvSpPr>
         <p:spPr>
           <a:xfrm>
-            <a:off x="640080" y="5943600"/>
-            <a:ext cx="10058400" cy="365760"/>
+            <a:off x="640080" y="3383280"/>
+            <a:ext cx="10972800" cy="914400"/>
           </a:xfrm>
           <a:prstGeom prst="rect">
             <a:avLst/>
@@ -4364,17 +4364,104 @@
           <a:p>
             <a:pPr algn="l">
               <a:spcAft>
-                <a:spcPts val="600"/>
+                <a:spcPts val="500"/>
+              </a:spcAft>
+              <a:defRPr sz="1800" b="0">
+                <a:solidFill>
+                  <a:srgbClr val="0A0A0A"/>
+                </a:solidFill>
+                <a:latin typeface="Arial"/>
+              </a:defRPr>
+            </a:pPr>
+            <a:r>
+              <a:t>Users: Solo founders building an AI SaaS product who need evidence-backed</a:t>
+            </a:r>
+          </a:p>
+          <a:p>
+            <a:pPr algn="l">
+              <a:spcAft>
+                <a:spcPts val="500"/>
+              </a:spcAft>
+              <a:defRPr sz="1800" b="0">
+                <a:solidFill>
+                  <a:srgbClr val="0A0A0A"/>
+                </a:solidFill>
+                <a:latin typeface="Arial"/>
+              </a:defRPr>
+            </a:pPr>
+            <a:r>
+              <a:t>AI operating costs before they commit.</a:t>
+            </a:r>
+          </a:p>
+        </p:txBody>
+      </p:sp>
+      <p:sp>
+        <p:nvSpPr>
+          <p:cNvPr id="8" name="TextBox 7"/>
+          <p:cNvSpPr txBox="1"/>
+          <p:nvPr/>
+        </p:nvSpPr>
+        <p:spPr>
+          <a:xfrm>
+            <a:off x="640080" y="4663440"/>
+            <a:ext cx="10972800" cy="1463040"/>
+          </a:xfrm>
+          <a:prstGeom prst="rect">
+            <a:avLst/>
+          </a:prstGeom>
+          <a:noFill/>
+        </p:spPr>
+        <p:txBody>
+          <a:bodyPr wrap="square">
+            <a:spAutoFit/>
+          </a:bodyPr>
+          <a:lstStyle/>
+          <a:p>
+            <a:pPr algn="l">
+              <a:spcAft>
+                <a:spcPts val="500"/>
               </a:spcAft>
               <a:defRPr sz="1400" b="0">
                 <a:solidFill>
-                  <a:srgbClr val="0000FF"/>
+                  <a:srgbClr val="555555"/>
                 </a:solidFill>
                 <a:latin typeface="Arial"/>
               </a:defRPr>
             </a:pPr>
             <a:r>
-              <a:t>github.com/pradeepgnd/cost-optimizer</a:t>
+              <a:t>Judging (100 pts): Impact 30 · Technical 20 · Innovation 15 · Demo 15 · Product &amp; UX 10 · Sponsor Tech 10</a:t>
+            </a:r>
+          </a:p>
+          <a:p>
+            <a:pPr algn="l">
+              <a:spcAft>
+                <a:spcPts val="500"/>
+              </a:spcAft>
+              <a:defRPr sz="1400" b="0">
+                <a:solidFill>
+                  <a:srgbClr val="555555"/>
+                </a:solidFill>
+                <a:latin typeface="Arial"/>
+              </a:defRPr>
+            </a:pPr>
+            <a:r>
+              <a:t>Demo video: 1–4 minutes (recommended 2:30–3:30). This spoken deck ~3:15.</a:t>
+            </a:r>
+          </a:p>
+          <a:p>
+            <a:pPr algn="l">
+              <a:spcAft>
+                <a:spcPts val="500"/>
+              </a:spcAft>
+              <a:defRPr sz="1400" b="0">
+                <a:solidFill>
+                  <a:srgbClr val="555555"/>
+                </a:solidFill>
+                <a:latin typeface="Arial"/>
+              </a:defRPr>
+            </a:pPr>
+            <a:r>
+              <a:t>Eight required deck points follow — consistent with README and demo.</a:t>
             </a:r>
           </a:p>
         </p:txBody>
@@ -4449,7 +4536,7 @@
         <p:spPr>
           <a:xfrm>
             <a:off x="0" y="0"/>
-            <a:ext cx="12191695" cy="1005840"/>
+            <a:ext cx="12191695" cy="960120"/>
           </a:xfrm>
           <a:prstGeom prst="rect">
             <a:avLst/>
@@ -4491,8 +4578,8 @@
         </p:nvSpPr>
         <p:spPr>
           <a:xfrm>
-            <a:off x="0" y="1005840"/>
-            <a:ext cx="12191695" cy="73152"/>
+            <a:off x="0" y="960120"/>
+            <a:ext cx="12191695" cy="64008"/>
           </a:xfrm>
           <a:prstGeom prst="rect">
             <a:avLst/>
@@ -4534,8 +4621,8 @@
         </p:nvSpPr>
         <p:spPr>
           <a:xfrm>
-            <a:off x="548640" y="274320"/>
-            <a:ext cx="10972800" cy="548640"/>
+            <a:off x="502920" y="256032"/>
+            <a:ext cx="11155680" cy="502920"/>
           </a:xfrm>
           <a:prstGeom prst="rect">
             <a:avLst/>
@@ -4550,9 +4637,9 @@
           <a:p>
             <a:pPr algn="l">
               <a:spcAft>
-                <a:spcPts val="600"/>
+                <a:spcPts val="500"/>
               </a:spcAft>
-              <a:defRPr sz="2800" b="1">
+              <a:defRPr sz="2400" b="1">
                 <a:solidFill>
                   <a:srgbClr val="0A0A0A"/>
                 </a:solidFill>
@@ -4560,7 +4647,7 @@
               </a:defRPr>
             </a:pPr>
             <a:r>
-              <a:t>Who it's for — and what you get</a:t>
+              <a:t>1–2 · Solution — input, process, output</a:t>
             </a:r>
           </a:p>
         </p:txBody>
@@ -4573,8 +4660,8 @@
         </p:nvSpPr>
         <p:spPr>
           <a:xfrm>
-            <a:off x="548640" y="1371600"/>
-            <a:ext cx="10972800" cy="548640"/>
+            <a:off x="502920" y="1234440"/>
+            <a:ext cx="11155680" cy="5212080"/>
           </a:xfrm>
           <a:prstGeom prst="rect">
             <a:avLst/>
@@ -4589,48 +4676,25 @@
           <a:p>
             <a:pPr algn="l">
               <a:spcAft>
-                <a:spcPts val="600"/>
+                <a:spcPts val="500"/>
               </a:spcAft>
-              <a:defRPr sz="1800" b="0">
-                <a:solidFill>
-                  <a:srgbClr val="3A3A3A"/>
+              <a:defRPr sz="1700" b="0">
+                <a:solidFill>
+                  <a:srgbClr val="0A0A0A"/>
                 </a:solidFill>
                 <a:latin typeface="Arial"/>
               </a:defRPr>
             </a:pPr>
             <a:r>
-              <a:t>Solo founders building an AI SaaS product who need costs before they commit.</a:t>
-            </a:r>
-          </a:p>
-        </p:txBody>
-      </p:sp>
-      <p:sp>
-        <p:nvSpPr>
-          <p:cNvPr id="7" name="TextBox 6"/>
-          <p:cNvSpPr txBox="1"/>
-          <p:nvPr/>
-        </p:nvSpPr>
-        <p:spPr>
-          <a:xfrm>
-            <a:off x="548640" y="2103120"/>
-            <a:ext cx="10972800" cy="4114800"/>
-          </a:xfrm>
-          <a:prstGeom prst="rect">
-            <a:avLst/>
-          </a:prstGeom>
-          <a:noFill/>
-        </p:spPr>
-        <p:txBody>
-          <a:bodyPr wrap="square">
-            <a:spAutoFit/>
-          </a:bodyPr>
-          <a:lstStyle/>
+              <a:t>Input: idea + 2–5 AI features + growth stages (+ optional revenue/budget).</a:t>
+            </a:r>
+          </a:p>
           <a:p>
             <a:pPr algn="l">
               <a:spcAft>
-                <a:spcPts val="600"/>
+                <a:spcPts val="500"/>
               </a:spcAft>
-              <a:defRPr sz="1800" b="0">
+              <a:defRPr sz="1700" b="0">
                 <a:solidFill>
                   <a:srgbClr val="0A0A0A"/>
                 </a:solidFill>
@@ -4638,15 +4702,15 @@
               </a:defRPr>
             </a:pPr>
             <a:r>
-              <a:t>Monthly AI cost per feature at Prototype 50 · Launch 500 · Traction 5,000 · Scale 50,000 users</a:t>
+              <a:t>  Live data via Zetaris/Nightshift, or SAMPLE/OFFLINE synthetic (real agent logic, no network).</a:t>
             </a:r>
           </a:p>
           <a:p>
             <a:pPr algn="l">
               <a:spcAft>
-                <a:spcPts val="600"/>
+                <a:spcPts val="500"/>
               </a:spcAft>
-              <a:defRPr sz="1800" b="0">
+              <a:defRPr sz="1700" b="0">
                 <a:solidFill>
                   <a:srgbClr val="0A0A0A"/>
                 </a:solidFill>
@@ -4654,15 +4718,15 @@
               </a:defRPr>
             </a:pPr>
             <a:r>
-              <a:t>Revenue and AI margin at each stage — plus the first stage over your budget</a:t>
+              <a:t>Process: Controller orchestrates Planner → Analyst → Critic under a spend cap.</a:t>
             </a:r>
           </a:p>
           <a:p>
             <a:pPr algn="l">
               <a:spcAft>
-                <a:spcPts val="600"/>
+                <a:spcPts val="500"/>
               </a:spcAft>
-              <a:defRPr sz="1800" b="0">
+              <a:defRPr sz="1700" b="0">
                 <a:solidFill>
                   <a:srgbClr val="0A0A0A"/>
                 </a:solidFill>
@@ -4670,15 +4734,15 @@
               </a:defRPr>
             </a:pPr>
             <a:r>
-              <a:t>Measured token counts on your own example inputs, next to estimates</a:t>
+              <a:t>Output (DecisionPack): monthly AI cost by stage, revenue/AI margin, measured vs estimated tokens,</a:t>
             </a:r>
           </a:p>
           <a:p>
             <a:pPr algn="l">
               <a:spcAft>
-                <a:spcPts val="600"/>
+                <a:spcPts val="500"/>
               </a:spcAft>
-              <a:defRPr sz="1800" b="0">
+              <a:defRPr sz="1700" b="0">
                 <a:solidFill>
                   <a:srgbClr val="0A0A0A"/>
                 </a:solidFill>
@@ -4686,23 +4750,68 @@
               </a:defRPr>
             </a:pPr>
             <a:r>
-              <a:t>Pass/fail quality checks, Critic flags, and a full step-by-step trace</a:t>
+              <a:t>  deterministic checks, Critic flags, limitations, JSONL trace of every step.</a:t>
             </a:r>
           </a:p>
           <a:p>
             <a:pPr algn="l">
               <a:spcAft>
-                <a:spcPts val="600"/>
+                <a:spcPts val="500"/>
               </a:spcAft>
-              <a:defRPr sz="1800" b="0">
+              <a:defRPr sz="1700" b="0">
                 <a:solidFill>
                   <a:srgbClr val="0A0A0A"/>
                 </a:solidFill>
                 <a:latin typeface="Arial"/>
               </a:defRPr>
             </a:pPr>
-            <a:r>
-              <a:t>Unknown stays unknown — labeled estimated / projected only / unknown, never filled in</a:t>
+          </a:p>
+          <a:p>
+            <a:pPr algn="l">
+              <a:spcAft>
+                <a:spcPts val="500"/>
+              </a:spcAft>
+              <a:defRPr sz="1700" b="0">
+                <a:solidFill>
+                  <a:srgbClr val="0A0A0A"/>
+                </a:solidFill>
+                <a:latin typeface="Arial"/>
+              </a:defRPr>
+            </a:pPr>
+            <a:r>
+              <a:t>Unmeasured values stay estimated / projected only / unknown — never invented.</a:t>
+            </a:r>
+          </a:p>
+          <a:p>
+            <a:pPr algn="l">
+              <a:spcAft>
+                <a:spcPts val="500"/>
+              </a:spcAft>
+              <a:defRPr sz="1700" b="0">
+                <a:solidFill>
+                  <a:srgbClr val="0A0A0A"/>
+                </a:solidFill>
+                <a:latin typeface="Arial"/>
+              </a:defRPr>
+            </a:pPr>
+            <a:r>
+              <a:t>We never claim dollar “savings.” Estimates are planning figures, not financial advice.</a:t>
+            </a:r>
+          </a:p>
+          <a:p>
+            <a:pPr algn="l">
+              <a:spcAft>
+                <a:spcPts val="500"/>
+              </a:spcAft>
+              <a:defRPr sz="1700" b="0">
+                <a:solidFill>
+                  <a:srgbClr val="0A0A0A"/>
+                </a:solidFill>
+                <a:latin typeface="Arial"/>
+              </a:defRPr>
+            </a:pPr>
+            <a:r>
+              <a:t>Why it matters: a founder can act on stage costs and gaps before they spend on build.</a:t>
             </a:r>
           </a:p>
         </p:txBody>
@@ -4777,7 +4886,7 @@
         <p:spPr>
           <a:xfrm>
             <a:off x="0" y="0"/>
-            <a:ext cx="12191695" cy="1005840"/>
+            <a:ext cx="12191695" cy="960120"/>
           </a:xfrm>
           <a:prstGeom prst="rect">
             <a:avLst/>
@@ -4819,8 +4928,8 @@
         </p:nvSpPr>
         <p:spPr>
           <a:xfrm>
-            <a:off x="0" y="1005840"/>
-            <a:ext cx="12191695" cy="73152"/>
+            <a:off x="0" y="960120"/>
+            <a:ext cx="12191695" cy="64008"/>
           </a:xfrm>
           <a:prstGeom prst="rect">
             <a:avLst/>
@@ -4862,8 +4971,8 @@
         </p:nvSpPr>
         <p:spPr>
           <a:xfrm>
-            <a:off x="548640" y="274320"/>
-            <a:ext cx="10972800" cy="548640"/>
+            <a:off x="502920" y="256032"/>
+            <a:ext cx="11155680" cy="502920"/>
           </a:xfrm>
           <a:prstGeom prst="rect">
             <a:avLst/>
@@ -4878,9 +4987,9 @@
           <a:p>
             <a:pPr algn="l">
               <a:spcAft>
-                <a:spcPts val="600"/>
+                <a:spcPts val="500"/>
               </a:spcAft>
-              <a:defRPr sz="2800" b="1">
+              <a:defRPr sz="2400" b="1">
                 <a:solidFill>
                   <a:srgbClr val="0A0A0A"/>
                 </a:solidFill>
@@ -4888,7 +4997,7 @@
               </a:defRPr>
             </a:pPr>
             <a:r>
-              <a:t>How the agent solves it</a:t>
+              <a:t>3 · Agent workflow — collaboration &amp; feedback loop</a:t>
             </a:r>
           </a:p>
         </p:txBody>
@@ -4901,8 +5010,8 @@
         </p:nvSpPr>
         <p:spPr>
           <a:xfrm>
-            <a:off x="548640" y="1371600"/>
-            <a:ext cx="10972800" cy="4572000"/>
+            <a:off x="502920" y="1188720"/>
+            <a:ext cx="11155680" cy="5303520"/>
           </a:xfrm>
           <a:prstGeom prst="rect">
             <a:avLst/>
@@ -4917,9 +5026,9 @@
           <a:p>
             <a:pPr algn="l">
               <a:spcAft>
-                <a:spcPts val="600"/>
+                <a:spcPts val="500"/>
               </a:spcAft>
-              <a:defRPr sz="2000" b="0">
+              <a:defRPr sz="1600" b="0">
                 <a:solidFill>
                   <a:srgbClr val="0A0A0A"/>
                 </a:solidFill>
@@ -4927,15 +5036,15 @@
               </a:defRPr>
             </a:pPr>
             <a:r>
-              <a:t>1  Recall earlier runs for this idea (Meterless H-MEM)</a:t>
+              <a:t>Named roles (real interdependence — not one agent with three labels):</a:t>
             </a:r>
           </a:p>
           <a:p>
             <a:pPr algn="l">
               <a:spcAft>
-                <a:spcPts val="600"/>
+                <a:spcPts val="500"/>
               </a:spcAft>
-              <a:defRPr sz="2000" b="0">
+              <a:defRPr sz="1600" b="0">
                 <a:solidFill>
                   <a:srgbClr val="0A0A0A"/>
                 </a:solidFill>
@@ -4943,15 +5052,15 @@
               </a:defRPr>
             </a:pPr>
             <a:r>
-              <a:t>2  Read dated model prices (Zetaris)</a:t>
+              <a:t>  • Planner — domain risks (Nemotron Lightning via Nightshift)</a:t>
             </a:r>
           </a:p>
           <a:p>
             <a:pPr algn="l">
               <a:spcAft>
-                <a:spcPts val="600"/>
+                <a:spcPts val="500"/>
               </a:spcAft>
-              <a:defRPr sz="2000" b="0">
+              <a:defRPr sz="1600" b="0">
                 <a:solidFill>
                   <a:srgbClr val="0A0A0A"/>
                 </a:solidFill>
@@ -4959,15 +5068,15 @@
               </a:defRPr>
             </a:pPr>
             <a:r>
-              <a:t>3  Pick frontier / mid-tier / open-source candidates per feature (Nightshift routes)</a:t>
+              <a:t>  • Analyst — Zetaris prices, candidates, measured feature×model samples</a:t>
             </a:r>
           </a:p>
           <a:p>
             <a:pPr algn="l">
               <a:spcAft>
-                <a:spcPts val="600"/>
+                <a:spcPts val="500"/>
               </a:spcAft>
-              <a:defRPr sz="2000" b="0">
+              <a:defRPr sz="1600" b="0">
                 <a:solidFill>
                   <a:srgbClr val="0A0A0A"/>
                 </a:solidFill>
@@ -4975,31 +5084,28 @@
               </a:defRPr>
             </a:pPr>
             <a:r>
-              <a:t>4  With approval + spend cap, run example inputs on models that can be measured</a:t>
+              <a:t>  • Critic — flags only; proposes one action (Nemotron Ultra via Nightshift)</a:t>
             </a:r>
           </a:p>
           <a:p>
             <a:pPr algn="l">
               <a:spcAft>
-                <a:spcPts val="600"/>
+                <a:spcPts val="500"/>
               </a:spcAft>
-              <a:defRPr sz="2000" b="0">
+              <a:defRPr sz="1600" b="0">
                 <a:solidFill>
                   <a:srgbClr val="0A0A0A"/>
                 </a:solidFill>
                 <a:latin typeface="Arial"/>
               </a:defRPr>
             </a:pPr>
-            <a:r>
-              <a:t>5  Deterministic quality checks; Critic flags problems (does not grade)</a:t>
-            </a:r>
           </a:p>
           <a:p>
             <a:pPr algn="l">
               <a:spcAft>
-                <a:spcPts val="600"/>
+                <a:spcPts val="500"/>
               </a:spcAft>
-              <a:defRPr sz="2000" b="0">
+              <a:defRPr sz="1600" b="0">
                 <a:solidFill>
                   <a:srgbClr val="0A0A0A"/>
                 </a:solidFill>
@@ -5007,7 +5113,55 @@
               </a:defRPr>
             </a:pPr>
             <a:r>
-              <a:t>6  Project costs by growth stage; write evidence back to Zetaris</a:t>
+              <a:t>Collaboration / loop: Critic findings → controller validates → ≤1 repair re-run.</a:t>
+            </a:r>
+          </a:p>
+          <a:p>
+            <a:pPr algn="l">
+              <a:spcAft>
+                <a:spcPts val="500"/>
+              </a:spcAft>
+              <a:defRPr sz="1600" b="0">
+                <a:solidFill>
+                  <a:srgbClr val="0A0A0A"/>
+                </a:solidFill>
+                <a:latin typeface="Arial"/>
+              </a:defRPr>
+            </a:pPr>
+            <a:r>
+              <a:t>Shared state: Meterless H-MEM recalls founder assumptions; saves accepted decisions.</a:t>
+            </a:r>
+          </a:p>
+          <a:p>
+            <a:pPr algn="l">
+              <a:spcAft>
+                <a:spcPts val="500"/>
+              </a:spcAft>
+              <a:defRPr sz="1600" b="0">
+                <a:solidFill>
+                  <a:srgbClr val="0A0A0A"/>
+                </a:solidFill>
+                <a:latin typeface="Arial"/>
+              </a:defRPr>
+            </a:pPr>
+            <a:r>
+              <a:t>Gates: spend reserved before each Nightshift call; ≤30 attempts; rubric + human review</a:t>
+            </a:r>
+          </a:p>
+          <a:p>
+            <a:pPr algn="l">
+              <a:spcAft>
+                <a:spcPts val="500"/>
+              </a:spcAft>
+              <a:defRPr sz="1600" b="0">
+                <a:solidFill>
+                  <a:srgbClr val="0A0A0A"/>
+                </a:solidFill>
+                <a:latin typeface="Arial"/>
+              </a:defRPr>
+            </a:pPr>
+            <a:r>
+              <a:t>  decide quality (models do not grade). Trace shows agent-to-agent steps.</a:t>
             </a:r>
           </a:p>
         </p:txBody>
@@ -5021,6 +5175,1044 @@
 </file>
 
 <file path=ppt/slides/slide4.xml><?xml version="1.0" encoding="utf-8"?>
+<p:sld xmlns:a="http://schemas.openxmlformats.org/drawingml/2006/main" xmlns:p="http://schemas.openxmlformats.org/presentationml/2006/main" xmlns:r="http://schemas.openxmlformats.org/officeDocument/2006/relationships">
+  <p:cSld>
+    <p:spTree>
+      <p:nvGrpSpPr>
+        <p:cNvPr id="1" name=""/>
+        <p:cNvGrpSpPr/>
+        <p:nvPr/>
+      </p:nvGrpSpPr>
+      <p:grpSpPr/>
+      <p:sp>
+        <p:nvSpPr>
+          <p:cNvPr id="2" name="Rectangle 1"/>
+          <p:cNvSpPr/>
+          <p:nvPr/>
+        </p:nvSpPr>
+        <p:spPr>
+          <a:xfrm>
+            <a:off x="0" y="0"/>
+            <a:ext cx="12191695" cy="6858000"/>
+          </a:xfrm>
+          <a:prstGeom prst="rect">
+            <a:avLst/>
+          </a:prstGeom>
+          <a:solidFill>
+            <a:srgbClr val="F5F4EE"/>
+          </a:solidFill>
+          <a:ln>
+            <a:noFill/>
+          </a:ln>
+        </p:spPr>
+        <p:style>
+          <a:lnRef idx="1">
+            <a:schemeClr val="accent1"/>
+          </a:lnRef>
+          <a:fillRef idx="3">
+            <a:schemeClr val="accent1"/>
+          </a:fillRef>
+          <a:effectRef idx="2">
+            <a:schemeClr val="accent1"/>
+          </a:effectRef>
+          <a:fontRef idx="minor">
+            <a:schemeClr val="lt1"/>
+          </a:fontRef>
+        </p:style>
+        <p:txBody>
+          <a:bodyPr rtlCol="0" anchor="ctr"/>
+          <a:lstStyle/>
+          <a:p>
+            <a:pPr algn="ctr"/>
+          </a:p>
+        </p:txBody>
+      </p:sp>
+      <p:sp>
+        <p:nvSpPr>
+          <p:cNvPr id="3" name="Rectangle 2"/>
+          <p:cNvSpPr/>
+          <p:nvPr/>
+        </p:nvSpPr>
+        <p:spPr>
+          <a:xfrm>
+            <a:off x="0" y="0"/>
+            <a:ext cx="12191695" cy="960120"/>
+          </a:xfrm>
+          <a:prstGeom prst="rect">
+            <a:avLst/>
+          </a:prstGeom>
+          <a:solidFill>
+            <a:srgbClr val="0000FF"/>
+          </a:solidFill>
+          <a:ln>
+            <a:noFill/>
+          </a:ln>
+        </p:spPr>
+        <p:style>
+          <a:lnRef idx="1">
+            <a:schemeClr val="accent1"/>
+          </a:lnRef>
+          <a:fillRef idx="3">
+            <a:schemeClr val="accent1"/>
+          </a:fillRef>
+          <a:effectRef idx="2">
+            <a:schemeClr val="accent1"/>
+          </a:effectRef>
+          <a:fontRef idx="minor">
+            <a:schemeClr val="lt1"/>
+          </a:fontRef>
+        </p:style>
+        <p:txBody>
+          <a:bodyPr rtlCol="0" anchor="ctr"/>
+          <a:lstStyle/>
+          <a:p>
+            <a:pPr algn="ctr"/>
+          </a:p>
+        </p:txBody>
+      </p:sp>
+      <p:sp>
+        <p:nvSpPr>
+          <p:cNvPr id="4" name="Rectangle 3"/>
+          <p:cNvSpPr/>
+          <p:nvPr/>
+        </p:nvSpPr>
+        <p:spPr>
+          <a:xfrm>
+            <a:off x="0" y="960120"/>
+            <a:ext cx="12191695" cy="64008"/>
+          </a:xfrm>
+          <a:prstGeom prst="rect">
+            <a:avLst/>
+          </a:prstGeom>
+          <a:solidFill>
+            <a:srgbClr val="0A0A0A"/>
+          </a:solidFill>
+          <a:ln>
+            <a:noFill/>
+          </a:ln>
+        </p:spPr>
+        <p:style>
+          <a:lnRef idx="1">
+            <a:schemeClr val="accent1"/>
+          </a:lnRef>
+          <a:fillRef idx="3">
+            <a:schemeClr val="accent1"/>
+          </a:fillRef>
+          <a:effectRef idx="2">
+            <a:schemeClr val="accent1"/>
+          </a:effectRef>
+          <a:fontRef idx="minor">
+            <a:schemeClr val="lt1"/>
+          </a:fontRef>
+        </p:style>
+        <p:txBody>
+          <a:bodyPr rtlCol="0" anchor="ctr"/>
+          <a:lstStyle/>
+          <a:p>
+            <a:pPr algn="ctr"/>
+          </a:p>
+        </p:txBody>
+      </p:sp>
+      <p:sp>
+        <p:nvSpPr>
+          <p:cNvPr id="5" name="TextBox 4"/>
+          <p:cNvSpPr txBox="1"/>
+          <p:nvPr/>
+        </p:nvSpPr>
+        <p:spPr>
+          <a:xfrm>
+            <a:off x="502920" y="256032"/>
+            <a:ext cx="11155680" cy="502920"/>
+          </a:xfrm>
+          <a:prstGeom prst="rect">
+            <a:avLst/>
+          </a:prstGeom>
+          <a:noFill/>
+        </p:spPr>
+        <p:txBody>
+          <a:bodyPr wrap="square">
+            <a:spAutoFit/>
+          </a:bodyPr>
+          <a:lstStyle/>
+          <a:p>
+            <a:pPr algn="l">
+              <a:spcAft>
+                <a:spcPts val="500"/>
+              </a:spcAft>
+              <a:defRPr sz="2400" b="1">
+                <a:solidFill>
+                  <a:srgbClr val="FFFFFF"/>
+                </a:solidFill>
+                <a:latin typeface="Arial"/>
+              </a:defRPr>
+            </a:pPr>
+            <a:r>
+              <a:t>4 · Technical stack</a:t>
+            </a:r>
+          </a:p>
+        </p:txBody>
+      </p:sp>
+      <p:sp>
+        <p:nvSpPr>
+          <p:cNvPr id="6" name="TextBox 5"/>
+          <p:cNvSpPr txBox="1"/>
+          <p:nvPr/>
+        </p:nvSpPr>
+        <p:spPr>
+          <a:xfrm>
+            <a:off x="502920" y="1234440"/>
+            <a:ext cx="11155680" cy="5212080"/>
+          </a:xfrm>
+          <a:prstGeom prst="rect">
+            <a:avLst/>
+          </a:prstGeom>
+          <a:noFill/>
+        </p:spPr>
+        <p:txBody>
+          <a:bodyPr wrap="square">
+            <a:spAutoFit/>
+          </a:bodyPr>
+          <a:lstStyle/>
+          <a:p>
+            <a:pPr algn="l">
+              <a:spcAft>
+                <a:spcPts val="500"/>
+              </a:spcAft>
+              <a:defRPr sz="1600" b="0">
+                <a:solidFill>
+                  <a:srgbClr val="0A0A0A"/>
+                </a:solidFill>
+                <a:latin typeface="Arial"/>
+              </a:defRPr>
+            </a:pPr>
+            <a:r>
+              <a:t>run.py — JSON in / JSON out · Streamlit UI (ui_service → same entry; no forked economics)</a:t>
+            </a:r>
+          </a:p>
+          <a:p>
+            <a:pPr algn="l">
+              <a:spcAft>
+                <a:spcPts val="500"/>
+              </a:spcAft>
+              <a:defRPr sz="1600" b="0">
+                <a:solidFill>
+                  <a:srgbClr val="0A0A0A"/>
+                </a:solidFill>
+                <a:latin typeface="Arial"/>
+              </a:defRPr>
+            </a:pPr>
+            <a:r>
+              <a:t>Controller · Pydantic contracts · Decimal economics · durable SQLite dispatch</a:t>
+            </a:r>
+          </a:p>
+          <a:p>
+            <a:pPr algn="l">
+              <a:spcAft>
+                <a:spcPts val="500"/>
+              </a:spcAft>
+              <a:defRPr sz="1600" b="0">
+                <a:solidFill>
+                  <a:srgbClr val="0A0A0A"/>
+                </a:solidFill>
+                <a:latin typeface="Arial"/>
+              </a:defRPr>
+            </a:pPr>
+            <a:r>
+              <a:t>Adapters: Zetaris · Meterless Nightshift · Meterless H-MEM (Node bridge, pinned engine)</a:t>
+            </a:r>
+          </a:p>
+          <a:p>
+            <a:pPr algn="l">
+              <a:spcAft>
+                <a:spcPts val="500"/>
+              </a:spcAft>
+              <a:defRPr sz="1600" b="0">
+                <a:solidFill>
+                  <a:srgbClr val="0A0A0A"/>
+                </a:solidFill>
+                <a:latin typeface="Arial"/>
+              </a:defRPr>
+            </a:pPr>
+            <a:r>
+              <a:t>NVIDIA Nemotron via Nightshift: Lightning (Planner) · Ultra (Critic) — logged model IDs</a:t>
+            </a:r>
+          </a:p>
+          <a:p>
+            <a:pPr algn="l">
+              <a:spcAft>
+                <a:spcPts val="500"/>
+              </a:spcAft>
+              <a:defRPr sz="1600" b="0">
+                <a:solidFill>
+                  <a:srgbClr val="0A0A0A"/>
+                </a:solidFill>
+                <a:latin typeface="Arial"/>
+              </a:defRPr>
+            </a:pPr>
+            <a:r>
+              <a:t>SAMPLE_MODE=true offline path · pytest + sample checker · organizer JSONL traces</a:t>
+            </a:r>
+          </a:p>
+          <a:p>
+            <a:pPr algn="l">
+              <a:spcAft>
+                <a:spcPts val="500"/>
+              </a:spcAft>
+              <a:defRPr sz="1600" b="0">
+                <a:solidFill>
+                  <a:srgbClr val="0A0A0A"/>
+                </a:solidFill>
+                <a:latin typeface="Arial"/>
+              </a:defRPr>
+            </a:pPr>
+            <a:r>
+              <a:t>Public repo: github.com/pradeepgnd/cost-optimizer · .env.example placeholders only</a:t>
+            </a:r>
+          </a:p>
+          <a:p>
+            <a:pPr algn="l">
+              <a:spcAft>
+                <a:spcPts val="500"/>
+              </a:spcAft>
+              <a:defRPr sz="1600" b="0">
+                <a:solidFill>
+                  <a:srgbClr val="0A0A0A"/>
+                </a:solidFill>
+                <a:latin typeface="Arial"/>
+              </a:defRPr>
+            </a:pPr>
+          </a:p>
+          <a:p>
+            <a:pPr algn="l">
+              <a:spcAft>
+                <a:spcPts val="500"/>
+              </a:spcAft>
+              <a:defRPr sz="1600" b="0">
+                <a:solidFill>
+                  <a:srgbClr val="0A0A0A"/>
+                </a:solidFill>
+                <a:latin typeface="Arial"/>
+              </a:defRPr>
+            </a:pPr>
+            <a:r>
+              <a:t>Framework choice is not scored; working sponsor integration and reliability are.</a:t>
+            </a:r>
+          </a:p>
+        </p:txBody>
+      </p:sp>
+    </p:spTree>
+  </p:cSld>
+  <p:clrMapOvr>
+    <a:masterClrMapping/>
+  </p:clrMapOvr>
+</p:sld>
+</file>
+
+<file path=ppt/slides/slide5.xml><?xml version="1.0" encoding="utf-8"?>
+<p:sld xmlns:a="http://schemas.openxmlformats.org/drawingml/2006/main" xmlns:p="http://schemas.openxmlformats.org/presentationml/2006/main" xmlns:r="http://schemas.openxmlformats.org/officeDocument/2006/relationships">
+  <p:cSld>
+    <p:spTree>
+      <p:nvGrpSpPr>
+        <p:cNvPr id="1" name=""/>
+        <p:cNvGrpSpPr/>
+        <p:nvPr/>
+      </p:nvGrpSpPr>
+      <p:grpSpPr/>
+      <p:sp>
+        <p:nvSpPr>
+          <p:cNvPr id="2" name="Rectangle 1"/>
+          <p:cNvSpPr/>
+          <p:nvPr/>
+        </p:nvSpPr>
+        <p:spPr>
+          <a:xfrm>
+            <a:off x="0" y="0"/>
+            <a:ext cx="12191695" cy="6858000"/>
+          </a:xfrm>
+          <a:prstGeom prst="rect">
+            <a:avLst/>
+          </a:prstGeom>
+          <a:solidFill>
+            <a:srgbClr val="F5F4EE"/>
+          </a:solidFill>
+          <a:ln>
+            <a:noFill/>
+          </a:ln>
+        </p:spPr>
+        <p:style>
+          <a:lnRef idx="1">
+            <a:schemeClr val="accent1"/>
+          </a:lnRef>
+          <a:fillRef idx="3">
+            <a:schemeClr val="accent1"/>
+          </a:fillRef>
+          <a:effectRef idx="2">
+            <a:schemeClr val="accent1"/>
+          </a:effectRef>
+          <a:fontRef idx="minor">
+            <a:schemeClr val="lt1"/>
+          </a:fontRef>
+        </p:style>
+        <p:txBody>
+          <a:bodyPr rtlCol="0" anchor="ctr"/>
+          <a:lstStyle/>
+          <a:p>
+            <a:pPr algn="ctr"/>
+          </a:p>
+        </p:txBody>
+      </p:sp>
+      <p:sp>
+        <p:nvSpPr>
+          <p:cNvPr id="3" name="Rectangle 2"/>
+          <p:cNvSpPr/>
+          <p:nvPr/>
+        </p:nvSpPr>
+        <p:spPr>
+          <a:xfrm>
+            <a:off x="0" y="0"/>
+            <a:ext cx="12191695" cy="960120"/>
+          </a:xfrm>
+          <a:prstGeom prst="rect">
+            <a:avLst/>
+          </a:prstGeom>
+          <a:solidFill>
+            <a:srgbClr val="FFFF00"/>
+          </a:solidFill>
+          <a:ln>
+            <a:noFill/>
+          </a:ln>
+        </p:spPr>
+        <p:style>
+          <a:lnRef idx="1">
+            <a:schemeClr val="accent1"/>
+          </a:lnRef>
+          <a:fillRef idx="3">
+            <a:schemeClr val="accent1"/>
+          </a:fillRef>
+          <a:effectRef idx="2">
+            <a:schemeClr val="accent1"/>
+          </a:effectRef>
+          <a:fontRef idx="minor">
+            <a:schemeClr val="lt1"/>
+          </a:fontRef>
+        </p:style>
+        <p:txBody>
+          <a:bodyPr rtlCol="0" anchor="ctr"/>
+          <a:lstStyle/>
+          <a:p>
+            <a:pPr algn="ctr"/>
+          </a:p>
+        </p:txBody>
+      </p:sp>
+      <p:sp>
+        <p:nvSpPr>
+          <p:cNvPr id="4" name="Rectangle 3"/>
+          <p:cNvSpPr/>
+          <p:nvPr/>
+        </p:nvSpPr>
+        <p:spPr>
+          <a:xfrm>
+            <a:off x="0" y="960120"/>
+            <a:ext cx="12191695" cy="64008"/>
+          </a:xfrm>
+          <a:prstGeom prst="rect">
+            <a:avLst/>
+          </a:prstGeom>
+          <a:solidFill>
+            <a:srgbClr val="0A0A0A"/>
+          </a:solidFill>
+          <a:ln>
+            <a:noFill/>
+          </a:ln>
+        </p:spPr>
+        <p:style>
+          <a:lnRef idx="1">
+            <a:schemeClr val="accent1"/>
+          </a:lnRef>
+          <a:fillRef idx="3">
+            <a:schemeClr val="accent1"/>
+          </a:fillRef>
+          <a:effectRef idx="2">
+            <a:schemeClr val="accent1"/>
+          </a:effectRef>
+          <a:fontRef idx="minor">
+            <a:schemeClr val="lt1"/>
+          </a:fontRef>
+        </p:style>
+        <p:txBody>
+          <a:bodyPr rtlCol="0" anchor="ctr"/>
+          <a:lstStyle/>
+          <a:p>
+            <a:pPr algn="ctr"/>
+          </a:p>
+        </p:txBody>
+      </p:sp>
+      <p:sp>
+        <p:nvSpPr>
+          <p:cNvPr id="5" name="TextBox 4"/>
+          <p:cNvSpPr txBox="1"/>
+          <p:nvPr/>
+        </p:nvSpPr>
+        <p:spPr>
+          <a:xfrm>
+            <a:off x="502920" y="256032"/>
+            <a:ext cx="11155680" cy="502920"/>
+          </a:xfrm>
+          <a:prstGeom prst="rect">
+            <a:avLst/>
+          </a:prstGeom>
+          <a:noFill/>
+        </p:spPr>
+        <p:txBody>
+          <a:bodyPr wrap="square">
+            <a:spAutoFit/>
+          </a:bodyPr>
+          <a:lstStyle/>
+          <a:p>
+            <a:pPr algn="l">
+              <a:spcAft>
+                <a:spcPts val="500"/>
+              </a:spcAft>
+              <a:defRPr sz="2400" b="1">
+                <a:solidFill>
+                  <a:srgbClr val="0A0A0A"/>
+                </a:solidFill>
+                <a:latin typeface="Arial"/>
+              </a:defRPr>
+            </a:pPr>
+            <a:r>
+              <a:t>5 · Zetaris + Meterless (+ NVIDIA) doing real work</a:t>
+            </a:r>
+          </a:p>
+        </p:txBody>
+      </p:sp>
+      <p:sp>
+        <p:nvSpPr>
+          <p:cNvPr id="6" name="TextBox 5"/>
+          <p:cNvSpPr txBox="1"/>
+          <p:nvPr/>
+        </p:nvSpPr>
+        <p:spPr>
+          <a:xfrm>
+            <a:off x="502920" y="1188720"/>
+            <a:ext cx="11155680" cy="5303520"/>
+          </a:xfrm>
+          <a:prstGeom prst="rect">
+            <a:avLst/>
+          </a:prstGeom>
+          <a:noFill/>
+        </p:spPr>
+        <p:txBody>
+          <a:bodyPr wrap="square">
+            <a:spAutoFit/>
+          </a:bodyPr>
+          <a:lstStyle/>
+          <a:p>
+            <a:pPr algn="l">
+              <a:spcAft>
+                <a:spcPts val="500"/>
+              </a:spcAft>
+              <a:defRPr sz="1500" b="0">
+                <a:solidFill>
+                  <a:srgbClr val="0A0A0A"/>
+                </a:solidFill>
+                <a:latin typeface="Arial"/>
+              </a:defRPr>
+            </a:pPr>
+            <a:r>
+              <a:t>Zetaris (required data layer): agent queries pinned price/catalog snapshots (typed, hashed);</a:t>
+            </a:r>
+          </a:p>
+          <a:p>
+            <a:pPr algn="l">
+              <a:spcAft>
+                <a:spcPts val="500"/>
+              </a:spcAft>
+              <a:defRPr sz="1500" b="0">
+                <a:solidFill>
+                  <a:srgbClr val="0A0A0A"/>
+                </a:solidFill>
+                <a:latin typeface="Arial"/>
+              </a:defRPr>
+            </a:pPr>
+            <a:r>
+              <a:t>  evidence publisher writes measured runs back; outbox + retry if write fails; query IDs in trace.</a:t>
+            </a:r>
+          </a:p>
+          <a:p>
+            <a:pPr algn="l">
+              <a:spcAft>
+                <a:spcPts val="500"/>
+              </a:spcAft>
+              <a:defRPr sz="1500" b="0">
+                <a:solidFill>
+                  <a:srgbClr val="0A0A0A"/>
+                </a:solidFill>
+                <a:latin typeface="Arial"/>
+              </a:defRPr>
+            </a:pPr>
+          </a:p>
+          <a:p>
+            <a:pPr algn="l">
+              <a:spcAft>
+                <a:spcPts val="500"/>
+              </a:spcAft>
+              <a:defRPr sz="1500" b="0">
+                <a:solidFill>
+                  <a:srgbClr val="0A0A0A"/>
+                </a:solidFill>
+                <a:latin typeface="Arial"/>
+              </a:defRPr>
+            </a:pPr>
+            <a:r>
+              <a:t>Meterless Nightshift (primary AI provider): every model call — Planner, candidates, Critic, repair;</a:t>
+            </a:r>
+          </a:p>
+          <a:p>
+            <a:pPr algn="l">
+              <a:spcAft>
+                <a:spcPts val="500"/>
+              </a:spcAft>
+              <a:defRPr sz="1500" b="0">
+                <a:solidFill>
+                  <a:srgbClr val="0A0A0A"/>
+                </a:solidFill>
+                <a:latin typeface="Arial"/>
+              </a:defRPr>
+            </a:pPr>
+            <a:r>
+              <a:t>  one real request returns usage (N in / N out) with requested + resolved model IDs.</a:t>
+            </a:r>
+          </a:p>
+          <a:p>
+            <a:pPr algn="l">
+              <a:spcAft>
+                <a:spcPts val="500"/>
+              </a:spcAft>
+              <a:defRPr sz="1500" b="0">
+                <a:solidFill>
+                  <a:srgbClr val="0A0A0A"/>
+                </a:solidFill>
+                <a:latin typeface="Arial"/>
+              </a:defRPr>
+            </a:pPr>
+          </a:p>
+          <a:p>
+            <a:pPr algn="l">
+              <a:spcAft>
+                <a:spcPts val="500"/>
+              </a:spcAft>
+              <a:defRPr sz="1500" b="0">
+                <a:solidFill>
+                  <a:srgbClr val="0A0A0A"/>
+                </a:solidFill>
+                <a:latin typeface="Arial"/>
+              </a:defRPr>
+            </a:pPr>
+            <a:r>
+              <a:t>Meterless Engine — H-MEM (working feature): recall at start, save decisions at end;</a:t>
+            </a:r>
+          </a:p>
+          <a:p>
+            <a:pPr algn="l">
+              <a:spcAft>
+                <a:spcPts val="500"/>
+              </a:spcAft>
+              <a:defRPr sz="1500" b="0">
+                <a:solidFill>
+                  <a:srgbClr val="0A0A0A"/>
+                </a:solidFill>
+                <a:latin typeface="Arial"/>
+              </a:defRPr>
+            </a:pPr>
+            <a:r>
+              <a:t>  conformance/self-test: save, restart recall, isolation, audit (tests/docs).</a:t>
+            </a:r>
+          </a:p>
+          <a:p>
+            <a:pPr algn="l">
+              <a:spcAft>
+                <a:spcPts val="500"/>
+              </a:spcAft>
+              <a:defRPr sz="1500" b="0">
+                <a:solidFill>
+                  <a:srgbClr val="0A0A0A"/>
+                </a:solidFill>
+                <a:latin typeface="Arial"/>
+              </a:defRPr>
+            </a:pPr>
+          </a:p>
+          <a:p>
+            <a:pPr algn="l">
+              <a:spcAft>
+                <a:spcPts val="500"/>
+              </a:spcAft>
+              <a:defRPr sz="1500" b="0">
+                <a:solidFill>
+                  <a:srgbClr val="0A0A0A"/>
+                </a:solidFill>
+                <a:latin typeface="Arial"/>
+              </a:defRPr>
+            </a:pPr>
+            <a:r>
+              <a:t>NVIDIA: Nemotron Lightning + Ultra through Nightshift in working Planner/Critic features</a:t>
+            </a:r>
+          </a:p>
+          <a:p>
+            <a:pPr algn="l">
+              <a:spcAft>
+                <a:spcPts val="500"/>
+              </a:spcAft>
+              <a:defRPr sz="1500" b="0">
+                <a:solidFill>
+                  <a:srgbClr val="0A0A0A"/>
+                </a:solidFill>
+                <a:latin typeface="Arial"/>
+              </a:defRPr>
+            </a:pPr>
+            <a:r>
+              <a:t>  (logs show the Nemotron model — not only meterless/auto).</a:t>
+            </a:r>
+          </a:p>
+        </p:txBody>
+      </p:sp>
+    </p:spTree>
+  </p:cSld>
+  <p:clrMapOvr>
+    <a:masterClrMapping/>
+  </p:clrMapOvr>
+</p:sld>
+</file>
+
+<file path=ppt/slides/slide6.xml><?xml version="1.0" encoding="utf-8"?>
+<p:sld xmlns:a="http://schemas.openxmlformats.org/drawingml/2006/main" xmlns:p="http://schemas.openxmlformats.org/presentationml/2006/main" xmlns:r="http://schemas.openxmlformats.org/officeDocument/2006/relationships">
+  <p:cSld>
+    <p:spTree>
+      <p:nvGrpSpPr>
+        <p:cNvPr id="1" name=""/>
+        <p:cNvGrpSpPr/>
+        <p:nvPr/>
+      </p:nvGrpSpPr>
+      <p:grpSpPr/>
+      <p:sp>
+        <p:nvSpPr>
+          <p:cNvPr id="2" name="Rectangle 1"/>
+          <p:cNvSpPr/>
+          <p:nvPr/>
+        </p:nvSpPr>
+        <p:spPr>
+          <a:xfrm>
+            <a:off x="0" y="0"/>
+            <a:ext cx="12191695" cy="6858000"/>
+          </a:xfrm>
+          <a:prstGeom prst="rect">
+            <a:avLst/>
+          </a:prstGeom>
+          <a:solidFill>
+            <a:srgbClr val="F5F4EE"/>
+          </a:solidFill>
+          <a:ln>
+            <a:noFill/>
+          </a:ln>
+        </p:spPr>
+        <p:style>
+          <a:lnRef idx="1">
+            <a:schemeClr val="accent1"/>
+          </a:lnRef>
+          <a:fillRef idx="3">
+            <a:schemeClr val="accent1"/>
+          </a:fillRef>
+          <a:effectRef idx="2">
+            <a:schemeClr val="accent1"/>
+          </a:effectRef>
+          <a:fontRef idx="minor">
+            <a:schemeClr val="lt1"/>
+          </a:fontRef>
+        </p:style>
+        <p:txBody>
+          <a:bodyPr rtlCol="0" anchor="ctr"/>
+          <a:lstStyle/>
+          <a:p>
+            <a:pPr algn="ctr"/>
+          </a:p>
+        </p:txBody>
+      </p:sp>
+      <p:sp>
+        <p:nvSpPr>
+          <p:cNvPr id="3" name="Rectangle 2"/>
+          <p:cNvSpPr/>
+          <p:nvPr/>
+        </p:nvSpPr>
+        <p:spPr>
+          <a:xfrm>
+            <a:off x="0" y="0"/>
+            <a:ext cx="12191695" cy="960120"/>
+          </a:xfrm>
+          <a:prstGeom prst="rect">
+            <a:avLst/>
+          </a:prstGeom>
+          <a:solidFill>
+            <a:srgbClr val="FF0000"/>
+          </a:solidFill>
+          <a:ln>
+            <a:noFill/>
+          </a:ln>
+        </p:spPr>
+        <p:style>
+          <a:lnRef idx="1">
+            <a:schemeClr val="accent1"/>
+          </a:lnRef>
+          <a:fillRef idx="3">
+            <a:schemeClr val="accent1"/>
+          </a:fillRef>
+          <a:effectRef idx="2">
+            <a:schemeClr val="accent1"/>
+          </a:effectRef>
+          <a:fontRef idx="minor">
+            <a:schemeClr val="lt1"/>
+          </a:fontRef>
+        </p:style>
+        <p:txBody>
+          <a:bodyPr rtlCol="0" anchor="ctr"/>
+          <a:lstStyle/>
+          <a:p>
+            <a:pPr algn="ctr"/>
+          </a:p>
+        </p:txBody>
+      </p:sp>
+      <p:sp>
+        <p:nvSpPr>
+          <p:cNvPr id="4" name="Rectangle 3"/>
+          <p:cNvSpPr/>
+          <p:nvPr/>
+        </p:nvSpPr>
+        <p:spPr>
+          <a:xfrm>
+            <a:off x="0" y="960120"/>
+            <a:ext cx="12191695" cy="64008"/>
+          </a:xfrm>
+          <a:prstGeom prst="rect">
+            <a:avLst/>
+          </a:prstGeom>
+          <a:solidFill>
+            <a:srgbClr val="0A0A0A"/>
+          </a:solidFill>
+          <a:ln>
+            <a:noFill/>
+          </a:ln>
+        </p:spPr>
+        <p:style>
+          <a:lnRef idx="1">
+            <a:schemeClr val="accent1"/>
+          </a:lnRef>
+          <a:fillRef idx="3">
+            <a:schemeClr val="accent1"/>
+          </a:fillRef>
+          <a:effectRef idx="2">
+            <a:schemeClr val="accent1"/>
+          </a:effectRef>
+          <a:fontRef idx="minor">
+            <a:schemeClr val="lt1"/>
+          </a:fontRef>
+        </p:style>
+        <p:txBody>
+          <a:bodyPr rtlCol="0" anchor="ctr"/>
+          <a:lstStyle/>
+          <a:p>
+            <a:pPr algn="ctr"/>
+          </a:p>
+        </p:txBody>
+      </p:sp>
+      <p:sp>
+        <p:nvSpPr>
+          <p:cNvPr id="5" name="TextBox 4"/>
+          <p:cNvSpPr txBox="1"/>
+          <p:nvPr/>
+        </p:nvSpPr>
+        <p:spPr>
+          <a:xfrm>
+            <a:off x="502920" y="256032"/>
+            <a:ext cx="11155680" cy="502920"/>
+          </a:xfrm>
+          <a:prstGeom prst="rect">
+            <a:avLst/>
+          </a:prstGeom>
+          <a:noFill/>
+        </p:spPr>
+        <p:txBody>
+          <a:bodyPr wrap="square">
+            <a:spAutoFit/>
+          </a:bodyPr>
+          <a:lstStyle/>
+          <a:p>
+            <a:pPr algn="l">
+              <a:spcAft>
+                <a:spcPts val="500"/>
+              </a:spcAft>
+              <a:defRPr sz="2400" b="1">
+                <a:solidFill>
+                  <a:srgbClr val="FFFFFF"/>
+                </a:solidFill>
+                <a:latin typeface="Arial"/>
+              </a:defRPr>
+            </a:pPr>
+            <a:r>
+              <a:t>6 · What was unique about our sponsor use</a:t>
+            </a:r>
+          </a:p>
+        </p:txBody>
+      </p:sp>
+      <p:sp>
+        <p:nvSpPr>
+          <p:cNvPr id="6" name="TextBox 5"/>
+          <p:cNvSpPr txBox="1"/>
+          <p:nvPr/>
+        </p:nvSpPr>
+        <p:spPr>
+          <a:xfrm>
+            <a:off x="502920" y="1234440"/>
+            <a:ext cx="11155680" cy="5212080"/>
+          </a:xfrm>
+          <a:prstGeom prst="rect">
+            <a:avLst/>
+          </a:prstGeom>
+          <a:noFill/>
+        </p:spPr>
+        <p:txBody>
+          <a:bodyPr wrap="square">
+            <a:spAutoFit/>
+          </a:bodyPr>
+          <a:lstStyle/>
+          <a:p>
+            <a:pPr algn="l">
+              <a:spcAft>
+                <a:spcPts val="500"/>
+              </a:spcAft>
+              <a:defRPr sz="1700" b="0">
+                <a:solidFill>
+                  <a:srgbClr val="0A0A0A"/>
+                </a:solidFill>
+                <a:latin typeface="Arial"/>
+              </a:defRPr>
+            </a:pPr>
+            <a:r>
+              <a:t>Same sponsor tools that run the agent also produce the cost evidence.</a:t>
+            </a:r>
+          </a:p>
+          <a:p>
+            <a:pPr algn="l">
+              <a:spcAft>
+                <a:spcPts val="500"/>
+              </a:spcAft>
+              <a:defRPr sz="1700" b="0">
+                <a:solidFill>
+                  <a:srgbClr val="0A0A0A"/>
+                </a:solidFill>
+                <a:latin typeface="Arial"/>
+              </a:defRPr>
+            </a:pPr>
+          </a:p>
+          <a:p>
+            <a:pPr algn="l">
+              <a:spcAft>
+                <a:spcPts val="500"/>
+              </a:spcAft>
+              <a:defRPr sz="1700" b="0">
+                <a:solidFill>
+                  <a:srgbClr val="0A0A0A"/>
+                </a:solidFill>
+                <a:latin typeface="Arial"/>
+              </a:defRPr>
+            </a:pPr>
+            <a:r>
+              <a:t>Live finding (26 Oct): shared Nightshift meterless-scope leaked prior answers into</a:t>
+            </a:r>
+          </a:p>
+          <a:p>
+            <a:pPr algn="l">
+              <a:spcAft>
+                <a:spcPts val="500"/>
+              </a:spcAft>
+              <a:defRPr sz="1700" b="0">
+                <a:solidFill>
+                  <a:srgbClr val="0A0A0A"/>
+                </a:solidFill>
+                <a:latin typeface="Arial"/>
+              </a:defRPr>
+            </a:pPr>
+            <a:r>
+              <a:t>similar prompts — identical text across models and inflated input tokens (e.g. 1542 vs 751).</a:t>
+            </a:r>
+          </a:p>
+          <a:p>
+            <a:pPr algn="l">
+              <a:spcAft>
+                <a:spcPts val="500"/>
+              </a:spcAft>
+              <a:defRPr sz="1700" b="0">
+                <a:solidFill>
+                  <a:srgbClr val="0A0A0A"/>
+                </a:solidFill>
+                <a:latin typeface="Arial"/>
+              </a:defRPr>
+            </a:pPr>
+          </a:p>
+          <a:p>
+            <a:pPr algn="l">
+              <a:spcAft>
+                <a:spcPts val="500"/>
+              </a:spcAft>
+              <a:defRPr sz="1700" b="0">
+                <a:solidFill>
+                  <a:srgbClr val="0A0A0A"/>
+                </a:solidFill>
+                <a:latin typeface="Arial"/>
+              </a:defRPr>
+            </a:pPr>
+            <a:r>
+              <a:t>Fix: per-request scopes (eval-&lt;random&gt;); re-measure; discard contaminated numbers.</a:t>
+            </a:r>
+          </a:p>
+          <a:p>
+            <a:pPr algn="l">
+              <a:spcAft>
+                <a:spcPts val="500"/>
+              </a:spcAft>
+              <a:defRPr sz="1700" b="0">
+                <a:solidFill>
+                  <a:srgbClr val="0A0A0A"/>
+                </a:solidFill>
+                <a:latin typeface="Arial"/>
+              </a:defRPr>
+            </a:pPr>
+          </a:p>
+          <a:p>
+            <a:pPr algn="l">
+              <a:spcAft>
+                <a:spcPts val="500"/>
+              </a:spcAft>
+              <a:defRPr sz="1700" b="0">
+                <a:solidFill>
+                  <a:srgbClr val="0A0A0A"/>
+                </a:solidFill>
+                <a:latin typeface="Arial"/>
+              </a:defRPr>
+            </a:pPr>
+            <a:r>
+              <a:t>For accurate token accounting, catching that was load-bearing sponsor use — not a bolt-on.</a:t>
+            </a:r>
+          </a:p>
+        </p:txBody>
+      </p:sp>
+    </p:spTree>
+  </p:cSld>
+  <p:clrMapOvr>
+    <a:masterClrMapping/>
+  </p:clrMapOvr>
+</p:sld>
+</file>
+
+<file path=ppt/slides/slide7.xml><?xml version="1.0" encoding="utf-8"?>
 <p:sld xmlns:a="http://schemas.openxmlformats.org/drawingml/2006/main" xmlns:p="http://schemas.openxmlformats.org/presentationml/2006/main" xmlns:r="http://schemas.openxmlformats.org/officeDocument/2006/relationships">
   <p:cSld>
     <p:spTree>
@@ -5081,8 +6273,8 @@
         </p:nvSpPr>
         <p:spPr>
           <a:xfrm>
-            <a:off x="457200" y="228600"/>
-            <a:ext cx="10972800" cy="411480"/>
+            <a:off x="365760" y="164592"/>
+            <a:ext cx="11430000" cy="365760"/>
           </a:xfrm>
           <a:prstGeom prst="rect">
             <a:avLst/>
@@ -5097,9 +6289,9 @@
           <a:p>
             <a:pPr algn="l">
               <a:spcAft>
-                <a:spcPts val="600"/>
+                <a:spcPts val="500"/>
               </a:spcAft>
-              <a:defRPr sz="2200" b="1">
+              <a:defRPr sz="1800" b="1">
                 <a:solidFill>
                   <a:srgbClr val="FFFF00"/>
                 </a:solidFill>
@@ -5107,7 +6299,7 @@
               </a:defRPr>
             </a:pPr>
             <a:r>
-              <a:t>Brief — idea, features, stages (Streamlit UI)</a:t>
+              <a:t>7 · Product visuals — Brief → Run (real Streamlit UI)</a:t>
             </a:r>
           </a:p>
         </p:txBody>
@@ -5128,14 +6320,77 @@
         </p:blipFill>
         <p:spPr>
           <a:xfrm>
-            <a:off x="457200" y="822960"/>
-            <a:ext cx="11247120" cy="7029450"/>
+            <a:off x="274320" y="594360"/>
+            <a:ext cx="5760720" cy="3600450"/>
           </a:xfrm>
           <a:prstGeom prst="rect">
             <a:avLst/>
           </a:prstGeom>
         </p:spPr>
       </p:pic>
+      <p:pic>
+        <p:nvPicPr>
+          <p:cNvPr id="5" name="Picture 4" descr="latest-run.png"/>
+          <p:cNvPicPr>
+            <a:picLocks noChangeAspect="1"/>
+          </p:cNvPicPr>
+          <p:nvPr/>
+        </p:nvPicPr>
+        <p:blipFill>
+          <a:blip r:embed="rId3"/>
+          <a:stretch>
+            <a:fillRect/>
+          </a:stretch>
+        </p:blipFill>
+        <p:spPr>
+          <a:xfrm>
+            <a:off x="6172200" y="594360"/>
+            <a:ext cx="5760720" cy="3600450"/>
+          </a:xfrm>
+          <a:prstGeom prst="rect">
+            <a:avLst/>
+          </a:prstGeom>
+        </p:spPr>
+      </p:pic>
+      <p:sp>
+        <p:nvSpPr>
+          <p:cNvPr id="6" name="TextBox 5"/>
+          <p:cNvSpPr txBox="1"/>
+          <p:nvPr/>
+        </p:nvSpPr>
+        <p:spPr>
+          <a:xfrm>
+            <a:off x="365760" y="6080760"/>
+            <a:ext cx="11430000" cy="365760"/>
+          </a:xfrm>
+          <a:prstGeom prst="rect">
+            <a:avLst/>
+          </a:prstGeom>
+          <a:noFill/>
+        </p:spPr>
+        <p:txBody>
+          <a:bodyPr wrap="square">
+            <a:spAutoFit/>
+          </a:bodyPr>
+          <a:lstStyle/>
+          <a:p>
+            <a:pPr algn="l">
+              <a:spcAft>
+                <a:spcPts val="500"/>
+              </a:spcAft>
+              <a:defRPr sz="1300" b="0">
+                <a:solidFill>
+                  <a:srgbClr val="FFFFFF"/>
+                </a:solidFill>
+                <a:latin typeface="Arial"/>
+              </a:defRPr>
+            </a:pPr>
+            <a:r>
+              <a:t>Approval + spend cap · progress: H-MEM → Zetaris → Nightshift → Planner/Critic (Nemotron)</a:t>
+            </a:r>
+          </a:p>
+        </p:txBody>
+      </p:sp>
     </p:spTree>
   </p:cSld>
   <p:clrMapOvr>
@@ -5144,7 +6399,7 @@
 </p:sld>
 </file>
 
-<file path=ppt/slides/slide5.xml><?xml version="1.0" encoding="utf-8"?>
+<file path=ppt/slides/slide8.xml><?xml version="1.0" encoding="utf-8"?>
 <p:sld xmlns:a="http://schemas.openxmlformats.org/drawingml/2006/main" xmlns:p="http://schemas.openxmlformats.org/presentationml/2006/main" xmlns:r="http://schemas.openxmlformats.org/officeDocument/2006/relationships">
   <p:cSld>
     <p:spTree>
@@ -5205,8 +6460,8 @@
         </p:nvSpPr>
         <p:spPr>
           <a:xfrm>
-            <a:off x="457200" y="228600"/>
-            <a:ext cx="10972800" cy="411480"/>
+            <a:off x="365760" y="164592"/>
+            <a:ext cx="11430000" cy="365760"/>
           </a:xfrm>
           <a:prstGeom prst="rect">
             <a:avLst/>
@@ -5221,9 +6476,9 @@
           <a:p>
             <a:pPr algn="l">
               <a:spcAft>
-                <a:spcPts val="600"/>
+                <a:spcPts val="500"/>
               </a:spcAft>
-              <a:defRPr sz="2200" b="1">
+              <a:defRPr sz="1800" b="1">
                 <a:solidFill>
                   <a:srgbClr val="FFFF00"/>
                 </a:solidFill>
@@ -5231,14 +6486,14 @@
               </a:defRPr>
             </a:pPr>
             <a:r>
-              <a:t>Run — approval, spend cap, Planner → Analyst → Critic</a:t>
+              <a:t>7 · Product visuals — final output a founder can use</a:t>
             </a:r>
           </a:p>
         </p:txBody>
       </p:sp>
       <p:pic>
         <p:nvPicPr>
-          <p:cNvPr id="4" name="Picture 3" descr="latest-run.png"/>
+          <p:cNvPr id="4" name="Picture 3" descr="latest-results.png"/>
           <p:cNvPicPr>
             <a:picLocks noChangeAspect="1"/>
           </p:cNvPicPr>
@@ -5252,14 +6507,53 @@
         </p:blipFill>
         <p:spPr>
           <a:xfrm>
-            <a:off x="457200" y="822960"/>
-            <a:ext cx="11247120" cy="7029450"/>
+            <a:off x="1005840" y="594360"/>
+            <a:ext cx="10058400" cy="6286500"/>
           </a:xfrm>
           <a:prstGeom prst="rect">
             <a:avLst/>
           </a:prstGeom>
         </p:spPr>
       </p:pic>
+      <p:sp>
+        <p:nvSpPr>
+          <p:cNvPr id="5" name="TextBox 4"/>
+          <p:cNvSpPr txBox="1"/>
+          <p:nvPr/>
+        </p:nvSpPr>
+        <p:spPr>
+          <a:xfrm>
+            <a:off x="365760" y="6080760"/>
+            <a:ext cx="11430000" cy="365760"/>
+          </a:xfrm>
+          <a:prstGeom prst="rect">
+            <a:avLst/>
+          </a:prstGeom>
+          <a:noFill/>
+        </p:spPr>
+        <p:txBody>
+          <a:bodyPr wrap="square">
+            <a:spAutoFit/>
+          </a:bodyPr>
+          <a:lstStyle/>
+          <a:p>
+            <a:pPr algn="l">
+              <a:spcAft>
+                <a:spcPts val="500"/>
+              </a:spcAft>
+              <a:defRPr sz="1300" b="0">
+                <a:solidFill>
+                  <a:srgbClr val="FFFFFF"/>
+                </a:solidFill>
+                <a:latin typeface="Arial"/>
+              </a:defRPr>
+            </a:pPr>
+            <a:r>
+              <a:t>Stage costs · margin · measured vs estimated · Critic flags · full trace — unknown stays unknown</a:t>
+            </a:r>
+          </a:p>
+        </p:txBody>
+      </p:sp>
     </p:spTree>
   </p:cSld>
   <p:clrMapOvr>
@@ -5268,7 +6562,7 @@
 </p:sld>
 </file>
 
-<file path=ppt/slides/slide6.xml><?xml version="1.0" encoding="utf-8"?>
+<file path=ppt/slides/slide9.xml><?xml version="1.0" encoding="utf-8"?>
 <p:sld xmlns:a="http://schemas.openxmlformats.org/drawingml/2006/main" xmlns:p="http://schemas.openxmlformats.org/presentationml/2006/main" xmlns:r="http://schemas.openxmlformats.org/officeDocument/2006/relationships">
   <p:cSld>
     <p:spTree>
@@ -5330,1324 +6624,6 @@
         <p:spPr>
           <a:xfrm>
             <a:off x="0" y="0"/>
-            <a:ext cx="12191695" cy="1005840"/>
-          </a:xfrm>
-          <a:prstGeom prst="rect">
-            <a:avLst/>
-          </a:prstGeom>
-          <a:solidFill>
-            <a:srgbClr val="0000FF"/>
-          </a:solidFill>
-          <a:ln>
-            <a:noFill/>
-          </a:ln>
-        </p:spPr>
-        <p:style>
-          <a:lnRef idx="1">
-            <a:schemeClr val="accent1"/>
-          </a:lnRef>
-          <a:fillRef idx="3">
-            <a:schemeClr val="accent1"/>
-          </a:fillRef>
-          <a:effectRef idx="2">
-            <a:schemeClr val="accent1"/>
-          </a:effectRef>
-          <a:fontRef idx="minor">
-            <a:schemeClr val="lt1"/>
-          </a:fontRef>
-        </p:style>
-        <p:txBody>
-          <a:bodyPr rtlCol="0" anchor="ctr"/>
-          <a:lstStyle/>
-          <a:p>
-            <a:pPr algn="ctr"/>
-          </a:p>
-        </p:txBody>
-      </p:sp>
-      <p:sp>
-        <p:nvSpPr>
-          <p:cNvPr id="4" name="Rectangle 3"/>
-          <p:cNvSpPr/>
-          <p:nvPr/>
-        </p:nvSpPr>
-        <p:spPr>
-          <a:xfrm>
-            <a:off x="0" y="1005840"/>
-            <a:ext cx="12191695" cy="73152"/>
-          </a:xfrm>
-          <a:prstGeom prst="rect">
-            <a:avLst/>
-          </a:prstGeom>
-          <a:solidFill>
-            <a:srgbClr val="0A0A0A"/>
-          </a:solidFill>
-          <a:ln>
-            <a:noFill/>
-          </a:ln>
-        </p:spPr>
-        <p:style>
-          <a:lnRef idx="1">
-            <a:schemeClr val="accent1"/>
-          </a:lnRef>
-          <a:fillRef idx="3">
-            <a:schemeClr val="accent1"/>
-          </a:fillRef>
-          <a:effectRef idx="2">
-            <a:schemeClr val="accent1"/>
-          </a:effectRef>
-          <a:fontRef idx="minor">
-            <a:schemeClr val="lt1"/>
-          </a:fontRef>
-        </p:style>
-        <p:txBody>
-          <a:bodyPr rtlCol="0" anchor="ctr"/>
-          <a:lstStyle/>
-          <a:p>
-            <a:pPr algn="ctr"/>
-          </a:p>
-        </p:txBody>
-      </p:sp>
-      <p:sp>
-        <p:nvSpPr>
-          <p:cNvPr id="5" name="TextBox 4"/>
-          <p:cNvSpPr txBox="1"/>
-          <p:nvPr/>
-        </p:nvSpPr>
-        <p:spPr>
-          <a:xfrm>
-            <a:off x="548640" y="274320"/>
-            <a:ext cx="10972800" cy="548640"/>
-          </a:xfrm>
-          <a:prstGeom prst="rect">
-            <a:avLst/>
-          </a:prstGeom>
-          <a:noFill/>
-        </p:spPr>
-        <p:txBody>
-          <a:bodyPr wrap="square">
-            <a:spAutoFit/>
-          </a:bodyPr>
-          <a:lstStyle/>
-          <a:p>
-            <a:pPr algn="l">
-              <a:spcAft>
-                <a:spcPts val="600"/>
-              </a:spcAft>
-              <a:defRPr sz="2800" b="1">
-                <a:solidFill>
-                  <a:srgbClr val="FFFFFF"/>
-                </a:solidFill>
-                <a:latin typeface="Arial"/>
-              </a:defRPr>
-            </a:pPr>
-            <a:r>
-              <a:t>Sponsor tech in the workflow</a:t>
-            </a:r>
-          </a:p>
-        </p:txBody>
-      </p:sp>
-      <p:sp>
-        <p:nvSpPr>
-          <p:cNvPr id="6" name="Rectangle 5"/>
-          <p:cNvSpPr/>
-          <p:nvPr/>
-        </p:nvSpPr>
-        <p:spPr>
-          <a:xfrm>
-            <a:off x="548640" y="1371600"/>
-            <a:ext cx="11064240" cy="1051560"/>
-          </a:xfrm>
-          <a:prstGeom prst="rect">
-            <a:avLst/>
-          </a:prstGeom>
-          <a:solidFill>
-            <a:srgbClr val="F5F4EE"/>
-          </a:solidFill>
-          <a:ln>
-            <a:noFill/>
-          </a:ln>
-        </p:spPr>
-        <p:style>
-          <a:lnRef idx="1">
-            <a:schemeClr val="accent1"/>
-          </a:lnRef>
-          <a:fillRef idx="3">
-            <a:schemeClr val="accent1"/>
-          </a:fillRef>
-          <a:effectRef idx="2">
-            <a:schemeClr val="accent1"/>
-          </a:effectRef>
-          <a:fontRef idx="minor">
-            <a:schemeClr val="lt1"/>
-          </a:fontRef>
-        </p:style>
-        <p:txBody>
-          <a:bodyPr rtlCol="0" anchor="ctr"/>
-          <a:lstStyle/>
-          <a:p>
-            <a:pPr algn="ctr"/>
-          </a:p>
-        </p:txBody>
-      </p:sp>
-      <p:sp>
-        <p:nvSpPr>
-          <p:cNvPr id="7" name="Rectangle 6"/>
-          <p:cNvSpPr/>
-          <p:nvPr/>
-        </p:nvSpPr>
-        <p:spPr>
-          <a:xfrm>
-            <a:off x="548640" y="1371600"/>
-            <a:ext cx="137160" cy="1051560"/>
-          </a:xfrm>
-          <a:prstGeom prst="rect">
-            <a:avLst/>
-          </a:prstGeom>
-          <a:solidFill>
-            <a:srgbClr val="FF0000"/>
-          </a:solidFill>
-          <a:ln>
-            <a:noFill/>
-          </a:ln>
-        </p:spPr>
-        <p:style>
-          <a:lnRef idx="1">
-            <a:schemeClr val="accent1"/>
-          </a:lnRef>
-          <a:fillRef idx="3">
-            <a:schemeClr val="accent1"/>
-          </a:fillRef>
-          <a:effectRef idx="2">
-            <a:schemeClr val="accent1"/>
-          </a:effectRef>
-          <a:fontRef idx="minor">
-            <a:schemeClr val="lt1"/>
-          </a:fontRef>
-        </p:style>
-        <p:txBody>
-          <a:bodyPr rtlCol="0" anchor="ctr"/>
-          <a:lstStyle/>
-          <a:p>
-            <a:pPr algn="ctr"/>
-          </a:p>
-        </p:txBody>
-      </p:sp>
-      <p:sp>
-        <p:nvSpPr>
-          <p:cNvPr id="8" name="TextBox 7"/>
-          <p:cNvSpPr txBox="1"/>
-          <p:nvPr/>
-        </p:nvSpPr>
-        <p:spPr>
-          <a:xfrm>
-            <a:off x="914400" y="1508760"/>
-            <a:ext cx="10515600" cy="365760"/>
-          </a:xfrm>
-          <a:prstGeom prst="rect">
-            <a:avLst/>
-          </a:prstGeom>
-          <a:noFill/>
-        </p:spPr>
-        <p:txBody>
-          <a:bodyPr wrap="square">
-            <a:spAutoFit/>
-          </a:bodyPr>
-          <a:lstStyle/>
-          <a:p>
-            <a:pPr algn="l">
-              <a:spcAft>
-                <a:spcPts val="600"/>
-              </a:spcAft>
-              <a:defRPr sz="1800" b="1">
-                <a:solidFill>
-                  <a:srgbClr val="0A0A0A"/>
-                </a:solidFill>
-                <a:latin typeface="Arial"/>
-              </a:defRPr>
-            </a:pPr>
-            <a:r>
-              <a:t>Zetaris</a:t>
-            </a:r>
-          </a:p>
-        </p:txBody>
-      </p:sp>
-      <p:sp>
-        <p:nvSpPr>
-          <p:cNvPr id="9" name="TextBox 8"/>
-          <p:cNvSpPr txBox="1"/>
-          <p:nvPr/>
-        </p:nvSpPr>
-        <p:spPr>
-          <a:xfrm>
-            <a:off x="914400" y="1874519"/>
-            <a:ext cx="10515600" cy="411480"/>
-          </a:xfrm>
-          <a:prstGeom prst="rect">
-            <a:avLst/>
-          </a:prstGeom>
-          <a:noFill/>
-        </p:spPr>
-        <p:txBody>
-          <a:bodyPr wrap="square">
-            <a:spAutoFit/>
-          </a:bodyPr>
-          <a:lstStyle/>
-          <a:p>
-            <a:pPr algn="l">
-              <a:spcAft>
-                <a:spcPts val="600"/>
-              </a:spcAft>
-              <a:defRPr sz="1600" b="0">
-                <a:solidFill>
-                  <a:srgbClr val="3A3A3A"/>
-                </a:solidFill>
-                <a:latin typeface="Arial"/>
-              </a:defRPr>
-            </a:pPr>
-            <a:r>
-              <a:t>Dated price snapshots in; measured evidence out (publisher + outbox replay)</a:t>
-            </a:r>
-          </a:p>
-        </p:txBody>
-      </p:sp>
-      <p:sp>
-        <p:nvSpPr>
-          <p:cNvPr id="10" name="Rectangle 9"/>
-          <p:cNvSpPr/>
-          <p:nvPr/>
-        </p:nvSpPr>
-        <p:spPr>
-          <a:xfrm>
-            <a:off x="548640" y="2560320"/>
-            <a:ext cx="11064240" cy="1051560"/>
-          </a:xfrm>
-          <a:prstGeom prst="rect">
-            <a:avLst/>
-          </a:prstGeom>
-          <a:solidFill>
-            <a:srgbClr val="F5F4EE"/>
-          </a:solidFill>
-          <a:ln>
-            <a:noFill/>
-          </a:ln>
-        </p:spPr>
-        <p:style>
-          <a:lnRef idx="1">
-            <a:schemeClr val="accent1"/>
-          </a:lnRef>
-          <a:fillRef idx="3">
-            <a:schemeClr val="accent1"/>
-          </a:fillRef>
-          <a:effectRef idx="2">
-            <a:schemeClr val="accent1"/>
-          </a:effectRef>
-          <a:fontRef idx="minor">
-            <a:schemeClr val="lt1"/>
-          </a:fontRef>
-        </p:style>
-        <p:txBody>
-          <a:bodyPr rtlCol="0" anchor="ctr"/>
-          <a:lstStyle/>
-          <a:p>
-            <a:pPr algn="ctr"/>
-          </a:p>
-        </p:txBody>
-      </p:sp>
-      <p:sp>
-        <p:nvSpPr>
-          <p:cNvPr id="11" name="Rectangle 10"/>
-          <p:cNvSpPr/>
-          <p:nvPr/>
-        </p:nvSpPr>
-        <p:spPr>
-          <a:xfrm>
-            <a:off x="548640" y="2560320"/>
-            <a:ext cx="137160" cy="1051560"/>
-          </a:xfrm>
-          <a:prstGeom prst="rect">
-            <a:avLst/>
-          </a:prstGeom>
-          <a:solidFill>
-            <a:srgbClr val="FF0000"/>
-          </a:solidFill>
-          <a:ln>
-            <a:noFill/>
-          </a:ln>
-        </p:spPr>
-        <p:style>
-          <a:lnRef idx="1">
-            <a:schemeClr val="accent1"/>
-          </a:lnRef>
-          <a:fillRef idx="3">
-            <a:schemeClr val="accent1"/>
-          </a:fillRef>
-          <a:effectRef idx="2">
-            <a:schemeClr val="accent1"/>
-          </a:effectRef>
-          <a:fontRef idx="minor">
-            <a:schemeClr val="lt1"/>
-          </a:fontRef>
-        </p:style>
-        <p:txBody>
-          <a:bodyPr rtlCol="0" anchor="ctr"/>
-          <a:lstStyle/>
-          <a:p>
-            <a:pPr algn="ctr"/>
-          </a:p>
-        </p:txBody>
-      </p:sp>
-      <p:sp>
-        <p:nvSpPr>
-          <p:cNvPr id="12" name="TextBox 11"/>
-          <p:cNvSpPr txBox="1"/>
-          <p:nvPr/>
-        </p:nvSpPr>
-        <p:spPr>
-          <a:xfrm>
-            <a:off x="914400" y="2697479"/>
-            <a:ext cx="10515600" cy="365760"/>
-          </a:xfrm>
-          <a:prstGeom prst="rect">
-            <a:avLst/>
-          </a:prstGeom>
-          <a:noFill/>
-        </p:spPr>
-        <p:txBody>
-          <a:bodyPr wrap="square">
-            <a:spAutoFit/>
-          </a:bodyPr>
-          <a:lstStyle/>
-          <a:p>
-            <a:pPr algn="l">
-              <a:spcAft>
-                <a:spcPts val="600"/>
-              </a:spcAft>
-              <a:defRPr sz="1800" b="1">
-                <a:solidFill>
-                  <a:srgbClr val="0A0A0A"/>
-                </a:solidFill>
-                <a:latin typeface="Arial"/>
-              </a:defRPr>
-            </a:pPr>
-            <a:r>
-              <a:t>Meterless Nightshift</a:t>
-            </a:r>
-          </a:p>
-        </p:txBody>
-      </p:sp>
-      <p:sp>
-        <p:nvSpPr>
-          <p:cNvPr id="13" name="TextBox 12"/>
-          <p:cNvSpPr txBox="1"/>
-          <p:nvPr/>
-        </p:nvSpPr>
-        <p:spPr>
-          <a:xfrm>
-            <a:off x="914400" y="3063239"/>
-            <a:ext cx="10515600" cy="411480"/>
-          </a:xfrm>
-          <a:prstGeom prst="rect">
-            <a:avLst/>
-          </a:prstGeom>
-          <a:noFill/>
-        </p:spPr>
-        <p:txBody>
-          <a:bodyPr wrap="square">
-            <a:spAutoFit/>
-          </a:bodyPr>
-          <a:lstStyle/>
-          <a:p>
-            <a:pPr algn="l">
-              <a:spcAft>
-                <a:spcPts val="600"/>
-              </a:spcAft>
-              <a:defRPr sz="1600" b="0">
-                <a:solidFill>
-                  <a:srgbClr val="3A3A3A"/>
-                </a:solidFill>
-                <a:latin typeface="Arial"/>
-              </a:defRPr>
-            </a:pPr>
-            <a:r>
-              <a:t>Every model call — Planner, candidates, Critic, one repair — with spend reservation</a:t>
-            </a:r>
-          </a:p>
-        </p:txBody>
-      </p:sp>
-      <p:sp>
-        <p:nvSpPr>
-          <p:cNvPr id="14" name="Rectangle 13"/>
-          <p:cNvSpPr/>
-          <p:nvPr/>
-        </p:nvSpPr>
-        <p:spPr>
-          <a:xfrm>
-            <a:off x="548640" y="3749039"/>
-            <a:ext cx="11064240" cy="1051560"/>
-          </a:xfrm>
-          <a:prstGeom prst="rect">
-            <a:avLst/>
-          </a:prstGeom>
-          <a:solidFill>
-            <a:srgbClr val="F5F4EE"/>
-          </a:solidFill>
-          <a:ln>
-            <a:noFill/>
-          </a:ln>
-        </p:spPr>
-        <p:style>
-          <a:lnRef idx="1">
-            <a:schemeClr val="accent1"/>
-          </a:lnRef>
-          <a:fillRef idx="3">
-            <a:schemeClr val="accent1"/>
-          </a:fillRef>
-          <a:effectRef idx="2">
-            <a:schemeClr val="accent1"/>
-          </a:effectRef>
-          <a:fontRef idx="minor">
-            <a:schemeClr val="lt1"/>
-          </a:fontRef>
-        </p:style>
-        <p:txBody>
-          <a:bodyPr rtlCol="0" anchor="ctr"/>
-          <a:lstStyle/>
-          <a:p>
-            <a:pPr algn="ctr"/>
-          </a:p>
-        </p:txBody>
-      </p:sp>
-      <p:sp>
-        <p:nvSpPr>
-          <p:cNvPr id="15" name="Rectangle 14"/>
-          <p:cNvSpPr/>
-          <p:nvPr/>
-        </p:nvSpPr>
-        <p:spPr>
-          <a:xfrm>
-            <a:off x="548640" y="3749039"/>
-            <a:ext cx="137160" cy="1051560"/>
-          </a:xfrm>
-          <a:prstGeom prst="rect">
-            <a:avLst/>
-          </a:prstGeom>
-          <a:solidFill>
-            <a:srgbClr val="FF0000"/>
-          </a:solidFill>
-          <a:ln>
-            <a:noFill/>
-          </a:ln>
-        </p:spPr>
-        <p:style>
-          <a:lnRef idx="1">
-            <a:schemeClr val="accent1"/>
-          </a:lnRef>
-          <a:fillRef idx="3">
-            <a:schemeClr val="accent1"/>
-          </a:fillRef>
-          <a:effectRef idx="2">
-            <a:schemeClr val="accent1"/>
-          </a:effectRef>
-          <a:fontRef idx="minor">
-            <a:schemeClr val="lt1"/>
-          </a:fontRef>
-        </p:style>
-        <p:txBody>
-          <a:bodyPr rtlCol="0" anchor="ctr"/>
-          <a:lstStyle/>
-          <a:p>
-            <a:pPr algn="ctr"/>
-          </a:p>
-        </p:txBody>
-      </p:sp>
-      <p:sp>
-        <p:nvSpPr>
-          <p:cNvPr id="16" name="TextBox 15"/>
-          <p:cNvSpPr txBox="1"/>
-          <p:nvPr/>
-        </p:nvSpPr>
-        <p:spPr>
-          <a:xfrm>
-            <a:off x="914400" y="3886200"/>
-            <a:ext cx="10515600" cy="365760"/>
-          </a:xfrm>
-          <a:prstGeom prst="rect">
-            <a:avLst/>
-          </a:prstGeom>
-          <a:noFill/>
-        </p:spPr>
-        <p:txBody>
-          <a:bodyPr wrap="square">
-            <a:spAutoFit/>
-          </a:bodyPr>
-          <a:lstStyle/>
-          <a:p>
-            <a:pPr algn="l">
-              <a:spcAft>
-                <a:spcPts val="600"/>
-              </a:spcAft>
-              <a:defRPr sz="1800" b="1">
-                <a:solidFill>
-                  <a:srgbClr val="0A0A0A"/>
-                </a:solidFill>
-                <a:latin typeface="Arial"/>
-              </a:defRPr>
-            </a:pPr>
-            <a:r>
-              <a:t>Meterless H-MEM</a:t>
-            </a:r>
-          </a:p>
-        </p:txBody>
-      </p:sp>
-      <p:sp>
-        <p:nvSpPr>
-          <p:cNvPr id="17" name="TextBox 16"/>
-          <p:cNvSpPr txBox="1"/>
-          <p:nvPr/>
-        </p:nvSpPr>
-        <p:spPr>
-          <a:xfrm>
-            <a:off x="914400" y="4251959"/>
-            <a:ext cx="10515600" cy="411480"/>
-          </a:xfrm>
-          <a:prstGeom prst="rect">
-            <a:avLst/>
-          </a:prstGeom>
-          <a:noFill/>
-        </p:spPr>
-        <p:txBody>
-          <a:bodyPr wrap="square">
-            <a:spAutoFit/>
-          </a:bodyPr>
-          <a:lstStyle/>
-          <a:p>
-            <a:pPr algn="l">
-              <a:spcAft>
-                <a:spcPts val="600"/>
-              </a:spcAft>
-              <a:defRPr sz="1600" b="0">
-                <a:solidFill>
-                  <a:srgbClr val="3A3A3A"/>
-                </a:solidFill>
-                <a:latin typeface="Arial"/>
-              </a:defRPr>
-            </a:pPr>
-            <a:r>
-              <a:t>Idea memory: recall confirmed assumptions; save accepted decisions</a:t>
-            </a:r>
-          </a:p>
-        </p:txBody>
-      </p:sp>
-      <p:sp>
-        <p:nvSpPr>
-          <p:cNvPr id="18" name="Rectangle 17"/>
-          <p:cNvSpPr/>
-          <p:nvPr/>
-        </p:nvSpPr>
-        <p:spPr>
-          <a:xfrm>
-            <a:off x="548640" y="4937759"/>
-            <a:ext cx="11064240" cy="1051560"/>
-          </a:xfrm>
-          <a:prstGeom prst="rect">
-            <a:avLst/>
-          </a:prstGeom>
-          <a:solidFill>
-            <a:srgbClr val="F5F4EE"/>
-          </a:solidFill>
-          <a:ln>
-            <a:noFill/>
-          </a:ln>
-        </p:spPr>
-        <p:style>
-          <a:lnRef idx="1">
-            <a:schemeClr val="accent1"/>
-          </a:lnRef>
-          <a:fillRef idx="3">
-            <a:schemeClr val="accent1"/>
-          </a:fillRef>
-          <a:effectRef idx="2">
-            <a:schemeClr val="accent1"/>
-          </a:effectRef>
-          <a:fontRef idx="minor">
-            <a:schemeClr val="lt1"/>
-          </a:fontRef>
-        </p:style>
-        <p:txBody>
-          <a:bodyPr rtlCol="0" anchor="ctr"/>
-          <a:lstStyle/>
-          <a:p>
-            <a:pPr algn="ctr"/>
-          </a:p>
-        </p:txBody>
-      </p:sp>
-      <p:sp>
-        <p:nvSpPr>
-          <p:cNvPr id="19" name="Rectangle 18"/>
-          <p:cNvSpPr/>
-          <p:nvPr/>
-        </p:nvSpPr>
-        <p:spPr>
-          <a:xfrm>
-            <a:off x="548640" y="4937759"/>
-            <a:ext cx="137160" cy="1051560"/>
-          </a:xfrm>
-          <a:prstGeom prst="rect">
-            <a:avLst/>
-          </a:prstGeom>
-          <a:solidFill>
-            <a:srgbClr val="FF0000"/>
-          </a:solidFill>
-          <a:ln>
-            <a:noFill/>
-          </a:ln>
-        </p:spPr>
-        <p:style>
-          <a:lnRef idx="1">
-            <a:schemeClr val="accent1"/>
-          </a:lnRef>
-          <a:fillRef idx="3">
-            <a:schemeClr val="accent1"/>
-          </a:fillRef>
-          <a:effectRef idx="2">
-            <a:schemeClr val="accent1"/>
-          </a:effectRef>
-          <a:fontRef idx="minor">
-            <a:schemeClr val="lt1"/>
-          </a:fontRef>
-        </p:style>
-        <p:txBody>
-          <a:bodyPr rtlCol="0" anchor="ctr"/>
-          <a:lstStyle/>
-          <a:p>
-            <a:pPr algn="ctr"/>
-          </a:p>
-        </p:txBody>
-      </p:sp>
-      <p:sp>
-        <p:nvSpPr>
-          <p:cNvPr id="20" name="TextBox 19"/>
-          <p:cNvSpPr txBox="1"/>
-          <p:nvPr/>
-        </p:nvSpPr>
-        <p:spPr>
-          <a:xfrm>
-            <a:off x="914400" y="5074920"/>
-            <a:ext cx="10515600" cy="365760"/>
-          </a:xfrm>
-          <a:prstGeom prst="rect">
-            <a:avLst/>
-          </a:prstGeom>
-          <a:noFill/>
-        </p:spPr>
-        <p:txBody>
-          <a:bodyPr wrap="square">
-            <a:spAutoFit/>
-          </a:bodyPr>
-          <a:lstStyle/>
-          <a:p>
-            <a:pPr algn="l">
-              <a:spcAft>
-                <a:spcPts val="600"/>
-              </a:spcAft>
-              <a:defRPr sz="1800" b="1">
-                <a:solidFill>
-                  <a:srgbClr val="0A0A0A"/>
-                </a:solidFill>
-                <a:latin typeface="Arial"/>
-              </a:defRPr>
-            </a:pPr>
-            <a:r>
-              <a:t>NVIDIA Nemotron</a:t>
-            </a:r>
-          </a:p>
-        </p:txBody>
-      </p:sp>
-      <p:sp>
-        <p:nvSpPr>
-          <p:cNvPr id="21" name="TextBox 20"/>
-          <p:cNvSpPr txBox="1"/>
-          <p:nvPr/>
-        </p:nvSpPr>
-        <p:spPr>
-          <a:xfrm>
-            <a:off x="914400" y="5440679"/>
-            <a:ext cx="10515600" cy="411480"/>
-          </a:xfrm>
-          <a:prstGeom prst="rect">
-            <a:avLst/>
-          </a:prstGeom>
-          <a:noFill/>
-        </p:spPr>
-        <p:txBody>
-          <a:bodyPr wrap="square">
-            <a:spAutoFit/>
-          </a:bodyPr>
-          <a:lstStyle/>
-          <a:p>
-            <a:pPr algn="l">
-              <a:spcAft>
-                <a:spcPts val="600"/>
-              </a:spcAft>
-              <a:defRPr sz="1600" b="0">
-                <a:solidFill>
-                  <a:srgbClr val="3A3A3A"/>
-                </a:solidFill>
-                <a:latin typeface="Arial"/>
-              </a:defRPr>
-            </a:pPr>
-            <a:r>
-              <a:t>Planner on Lightning; Critic on Ultra — both through Nightshift</a:t>
-            </a:r>
-          </a:p>
-        </p:txBody>
-      </p:sp>
-    </p:spTree>
-  </p:cSld>
-  <p:clrMapOvr>
-    <a:masterClrMapping/>
-  </p:clrMapOvr>
-</p:sld>
-</file>
-
-<file path=ppt/slides/slide7.xml><?xml version="1.0" encoding="utf-8"?>
-<p:sld xmlns:a="http://schemas.openxmlformats.org/drawingml/2006/main" xmlns:p="http://schemas.openxmlformats.org/presentationml/2006/main" xmlns:r="http://schemas.openxmlformats.org/officeDocument/2006/relationships">
-  <p:cSld>
-    <p:spTree>
-      <p:nvGrpSpPr>
-        <p:cNvPr id="1" name=""/>
-        <p:cNvGrpSpPr/>
-        <p:nvPr/>
-      </p:nvGrpSpPr>
-      <p:grpSpPr/>
-      <p:sp>
-        <p:nvSpPr>
-          <p:cNvPr id="2" name="Rectangle 1"/>
-          <p:cNvSpPr/>
-          <p:nvPr/>
-        </p:nvSpPr>
-        <p:spPr>
-          <a:xfrm>
-            <a:off x="0" y="0"/>
-            <a:ext cx="12191695" cy="6858000"/>
-          </a:xfrm>
-          <a:prstGeom prst="rect">
-            <a:avLst/>
-          </a:prstGeom>
-          <a:solidFill>
-            <a:srgbClr val="0A0A0A"/>
-          </a:solidFill>
-          <a:ln>
-            <a:noFill/>
-          </a:ln>
-        </p:spPr>
-        <p:style>
-          <a:lnRef idx="1">
-            <a:schemeClr val="accent1"/>
-          </a:lnRef>
-          <a:fillRef idx="3">
-            <a:schemeClr val="accent1"/>
-          </a:fillRef>
-          <a:effectRef idx="2">
-            <a:schemeClr val="accent1"/>
-          </a:effectRef>
-          <a:fontRef idx="minor">
-            <a:schemeClr val="lt1"/>
-          </a:fontRef>
-        </p:style>
-        <p:txBody>
-          <a:bodyPr rtlCol="0" anchor="ctr"/>
-          <a:lstStyle/>
-          <a:p>
-            <a:pPr algn="ctr"/>
-          </a:p>
-        </p:txBody>
-      </p:sp>
-      <p:sp>
-        <p:nvSpPr>
-          <p:cNvPr id="3" name="TextBox 2"/>
-          <p:cNvSpPr txBox="1"/>
-          <p:nvPr/>
-        </p:nvSpPr>
-        <p:spPr>
-          <a:xfrm>
-            <a:off x="457200" y="228600"/>
-            <a:ext cx="10972800" cy="411480"/>
-          </a:xfrm>
-          <a:prstGeom prst="rect">
-            <a:avLst/>
-          </a:prstGeom>
-          <a:noFill/>
-        </p:spPr>
-        <p:txBody>
-          <a:bodyPr wrap="square">
-            <a:spAutoFit/>
-          </a:bodyPr>
-          <a:lstStyle/>
-          <a:p>
-            <a:pPr algn="l">
-              <a:spcAft>
-                <a:spcPts val="600"/>
-              </a:spcAft>
-              <a:defRPr sz="2200" b="1">
-                <a:solidFill>
-                  <a:srgbClr val="FFFF00"/>
-                </a:solidFill>
-                <a:latin typeface="Arial"/>
-              </a:defRPr>
-            </a:pPr>
-            <a:r>
-              <a:t>Results — monthly AI cost by growth stage</a:t>
-            </a:r>
-          </a:p>
-        </p:txBody>
-      </p:sp>
-      <p:pic>
-        <p:nvPicPr>
-          <p:cNvPr id="4" name="Picture 3" descr="latest-results.png"/>
-          <p:cNvPicPr>
-            <a:picLocks noChangeAspect="1"/>
-          </p:cNvPicPr>
-          <p:nvPr/>
-        </p:nvPicPr>
-        <p:blipFill>
-          <a:blip r:embed="rId2"/>
-          <a:stretch>
-            <a:fillRect/>
-          </a:stretch>
-        </p:blipFill>
-        <p:spPr>
-          <a:xfrm>
-            <a:off x="457200" y="822960"/>
-            <a:ext cx="11247120" cy="7029450"/>
-          </a:xfrm>
-          <a:prstGeom prst="rect">
-            <a:avLst/>
-          </a:prstGeom>
-        </p:spPr>
-      </p:pic>
-    </p:spTree>
-  </p:cSld>
-  <p:clrMapOvr>
-    <a:masterClrMapping/>
-  </p:clrMapOvr>
-</p:sld>
-</file>
-
-<file path=ppt/slides/slide8.xml><?xml version="1.0" encoding="utf-8"?>
-<p:sld xmlns:a="http://schemas.openxmlformats.org/drawingml/2006/main" xmlns:p="http://schemas.openxmlformats.org/presentationml/2006/main" xmlns:r="http://schemas.openxmlformats.org/officeDocument/2006/relationships">
-  <p:cSld>
-    <p:spTree>
-      <p:nvGrpSpPr>
-        <p:cNvPr id="1" name=""/>
-        <p:cNvGrpSpPr/>
-        <p:nvPr/>
-      </p:nvGrpSpPr>
-      <p:grpSpPr/>
-      <p:sp>
-        <p:nvSpPr>
-          <p:cNvPr id="2" name="Rectangle 1"/>
-          <p:cNvSpPr/>
-          <p:nvPr/>
-        </p:nvSpPr>
-        <p:spPr>
-          <a:xfrm>
-            <a:off x="0" y="0"/>
-            <a:ext cx="12191695" cy="6858000"/>
-          </a:xfrm>
-          <a:prstGeom prst="rect">
-            <a:avLst/>
-          </a:prstGeom>
-          <a:solidFill>
-            <a:srgbClr val="F5F4EE"/>
-          </a:solidFill>
-          <a:ln>
-            <a:noFill/>
-          </a:ln>
-        </p:spPr>
-        <p:style>
-          <a:lnRef idx="1">
-            <a:schemeClr val="accent1"/>
-          </a:lnRef>
-          <a:fillRef idx="3">
-            <a:schemeClr val="accent1"/>
-          </a:fillRef>
-          <a:effectRef idx="2">
-            <a:schemeClr val="accent1"/>
-          </a:effectRef>
-          <a:fontRef idx="minor">
-            <a:schemeClr val="lt1"/>
-          </a:fontRef>
-        </p:style>
-        <p:txBody>
-          <a:bodyPr rtlCol="0" anchor="ctr"/>
-          <a:lstStyle/>
-          <a:p>
-            <a:pPr algn="ctr"/>
-          </a:p>
-        </p:txBody>
-      </p:sp>
-      <p:sp>
-        <p:nvSpPr>
-          <p:cNvPr id="3" name="Rectangle 2"/>
-          <p:cNvSpPr/>
-          <p:nvPr/>
-        </p:nvSpPr>
-        <p:spPr>
-          <a:xfrm>
-            <a:off x="0" y="0"/>
-            <a:ext cx="12191695" cy="1005840"/>
-          </a:xfrm>
-          <a:prstGeom prst="rect">
-            <a:avLst/>
-          </a:prstGeom>
-          <a:solidFill>
-            <a:srgbClr val="FFFF00"/>
-          </a:solidFill>
-          <a:ln>
-            <a:noFill/>
-          </a:ln>
-        </p:spPr>
-        <p:style>
-          <a:lnRef idx="1">
-            <a:schemeClr val="accent1"/>
-          </a:lnRef>
-          <a:fillRef idx="3">
-            <a:schemeClr val="accent1"/>
-          </a:fillRef>
-          <a:effectRef idx="2">
-            <a:schemeClr val="accent1"/>
-          </a:effectRef>
-          <a:fontRef idx="minor">
-            <a:schemeClr val="lt1"/>
-          </a:fontRef>
-        </p:style>
-        <p:txBody>
-          <a:bodyPr rtlCol="0" anchor="ctr"/>
-          <a:lstStyle/>
-          <a:p>
-            <a:pPr algn="ctr"/>
-          </a:p>
-        </p:txBody>
-      </p:sp>
-      <p:sp>
-        <p:nvSpPr>
-          <p:cNvPr id="4" name="Rectangle 3"/>
-          <p:cNvSpPr/>
-          <p:nvPr/>
-        </p:nvSpPr>
-        <p:spPr>
-          <a:xfrm>
-            <a:off x="0" y="1005840"/>
-            <a:ext cx="12191695" cy="73152"/>
-          </a:xfrm>
-          <a:prstGeom prst="rect">
-            <a:avLst/>
-          </a:prstGeom>
-          <a:solidFill>
-            <a:srgbClr val="0A0A0A"/>
-          </a:solidFill>
-          <a:ln>
-            <a:noFill/>
-          </a:ln>
-        </p:spPr>
-        <p:style>
-          <a:lnRef idx="1">
-            <a:schemeClr val="accent1"/>
-          </a:lnRef>
-          <a:fillRef idx="3">
-            <a:schemeClr val="accent1"/>
-          </a:fillRef>
-          <a:effectRef idx="2">
-            <a:schemeClr val="accent1"/>
-          </a:effectRef>
-          <a:fontRef idx="minor">
-            <a:schemeClr val="lt1"/>
-          </a:fontRef>
-        </p:style>
-        <p:txBody>
-          <a:bodyPr rtlCol="0" anchor="ctr"/>
-          <a:lstStyle/>
-          <a:p>
-            <a:pPr algn="ctr"/>
-          </a:p>
-        </p:txBody>
-      </p:sp>
-      <p:sp>
-        <p:nvSpPr>
-          <p:cNvPr id="5" name="TextBox 4"/>
-          <p:cNvSpPr txBox="1"/>
-          <p:nvPr/>
-        </p:nvSpPr>
-        <p:spPr>
-          <a:xfrm>
-            <a:off x="548640" y="274320"/>
-            <a:ext cx="10972800" cy="548640"/>
-          </a:xfrm>
-          <a:prstGeom prst="rect">
-            <a:avLst/>
-          </a:prstGeom>
-          <a:noFill/>
-        </p:spPr>
-        <p:txBody>
-          <a:bodyPr wrap="square">
-            <a:spAutoFit/>
-          </a:bodyPr>
-          <a:lstStyle/>
-          <a:p>
-            <a:pPr algn="l">
-              <a:spcAft>
-                <a:spcPts val="600"/>
-              </a:spcAft>
-              <a:defRPr sz="2600" b="1">
-                <a:solidFill>
-                  <a:srgbClr val="0A0A0A"/>
-                </a:solidFill>
-                <a:latin typeface="Arial"/>
-              </a:defRPr>
-            </a:pPr>
-            <a:r>
-              <a:t>Explain why — measured vs estimated · checks · Critic</a:t>
-            </a:r>
-          </a:p>
-        </p:txBody>
-      </p:sp>
-      <p:sp>
-        <p:nvSpPr>
-          <p:cNvPr id="6" name="TextBox 5"/>
-          <p:cNvSpPr txBox="1"/>
-          <p:nvPr/>
-        </p:nvSpPr>
-        <p:spPr>
-          <a:xfrm>
-            <a:off x="548640" y="1371600"/>
-            <a:ext cx="5669280" cy="3657600"/>
-          </a:xfrm>
-          <a:prstGeom prst="rect">
-            <a:avLst/>
-          </a:prstGeom>
-          <a:noFill/>
-        </p:spPr>
-        <p:txBody>
-          <a:bodyPr wrap="square">
-            <a:spAutoFit/>
-          </a:bodyPr>
-          <a:lstStyle/>
-          <a:p>
-            <a:pPr algn="l">
-              <a:spcAft>
-                <a:spcPts val="600"/>
-              </a:spcAft>
-              <a:defRPr sz="1800" b="0">
-                <a:solidFill>
-                  <a:srgbClr val="0A0A0A"/>
-                </a:solidFill>
-                <a:latin typeface="Arial"/>
-              </a:defRPr>
-            </a:pPr>
-            <a:r>
-              <a:t>Estimated tokens next to API-measured counts</a:t>
-            </a:r>
-          </a:p>
-          <a:p>
-            <a:pPr algn="l">
-              <a:spcAft>
-                <a:spcPts val="600"/>
-              </a:spcAft>
-              <a:defRPr sz="1800" b="0">
-                <a:solidFill>
-                  <a:srgbClr val="0A0A0A"/>
-                </a:solidFill>
-                <a:latin typeface="Arial"/>
-              </a:defRPr>
-            </a:pPr>
-            <a:r>
-              <a:t>Unrun models: “projected only” — not guessed</a:t>
-            </a:r>
-          </a:p>
-          <a:p>
-            <a:pPr algn="l">
-              <a:spcAft>
-                <a:spcPts val="600"/>
-              </a:spcAft>
-              <a:defRPr sz="1800" b="0">
-                <a:solidFill>
-                  <a:srgbClr val="0A0A0A"/>
-                </a:solidFill>
-                <a:latin typeface="Arial"/>
-              </a:defRPr>
-            </a:pPr>
-            <a:r>
-              <a:t>Deterministic pass/fail + pending human review</a:t>
-            </a:r>
-          </a:p>
-          <a:p>
-            <a:pPr algn="l">
-              <a:spcAft>
-                <a:spcPts val="600"/>
-              </a:spcAft>
-              <a:defRPr sz="1800" b="0">
-                <a:solidFill>
-                  <a:srgbClr val="0A0A0A"/>
-                </a:solidFill>
-                <a:latin typeface="Arial"/>
-              </a:defRPr>
-            </a:pPr>
-            <a:r>
-              <a:t>Critic flags issues; controller validates one action</a:t>
-            </a:r>
-          </a:p>
-          <a:p>
-            <a:pPr algn="l">
-              <a:spcAft>
-                <a:spcPts val="600"/>
-              </a:spcAft>
-              <a:defRPr sz="1800" b="0">
-                <a:solidFill>
-                  <a:srgbClr val="0A0A0A"/>
-                </a:solidFill>
-                <a:latin typeface="Arial"/>
-              </a:defRPr>
-            </a:pPr>
-            <a:r>
-              <a:t>Full JSONL trace: every Zetaris query &amp; model request</a:t>
-            </a:r>
-          </a:p>
-        </p:txBody>
-      </p:sp>
-      <p:pic>
-        <p:nvPicPr>
-          <p:cNvPr id="7" name="Picture 6" descr="superdesign-draft-1.png"/>
-          <p:cNvPicPr>
-            <a:picLocks noChangeAspect="1"/>
-          </p:cNvPicPr>
-          <p:nvPr/>
-        </p:nvPicPr>
-        <p:blipFill>
-          <a:blip r:embed="rId2"/>
-          <a:stretch>
-            <a:fillRect/>
-          </a:stretch>
-        </p:blipFill>
-        <p:spPr>
-          <a:xfrm>
-            <a:off x="6400800" y="1371600"/>
-            <a:ext cx="5120640" cy="3200400"/>
-          </a:xfrm>
-          <a:prstGeom prst="rect">
-            <a:avLst/>
-          </a:prstGeom>
-        </p:spPr>
-      </p:pic>
-      <p:sp>
-        <p:nvSpPr>
-          <p:cNvPr id="8" name="TextBox 7"/>
-          <p:cNvSpPr txBox="1"/>
-          <p:nvPr/>
-        </p:nvSpPr>
-        <p:spPr>
-          <a:xfrm>
-            <a:off x="6400800" y="5943600"/>
-            <a:ext cx="5120640" cy="365760"/>
-          </a:xfrm>
-          <a:prstGeom prst="rect">
-            <a:avLst/>
-          </a:prstGeom>
-          <a:noFill/>
-        </p:spPr>
-        <p:txBody>
-          <a:bodyPr wrap="square">
-            <a:spAutoFit/>
-          </a:bodyPr>
-          <a:lstStyle/>
-          <a:p>
-            <a:pPr algn="l">
-              <a:spcAft>
-                <a:spcPts val="600"/>
-              </a:spcAft>
-              <a:defRPr sz="1100" b="0">
-                <a:solidFill>
-                  <a:srgbClr val="555555"/>
-                </a:solidFill>
-                <a:latin typeface="Arial"/>
-              </a:defRPr>
-            </a:pPr>
-            <a:r>
-              <a:t>UI exploration draft (Superdesign) — Streamlit ships the live Brief→Run→Results flow</a:t>
-            </a:r>
-          </a:p>
-        </p:txBody>
-      </p:sp>
-    </p:spTree>
-  </p:cSld>
-  <p:clrMapOvr>
-    <a:masterClrMapping/>
-  </p:clrMapOvr>
-</p:sld>
-</file>
-
-<file path=ppt/slides/slide9.xml><?xml version="1.0" encoding="utf-8"?>
-<p:sld xmlns:a="http://schemas.openxmlformats.org/drawingml/2006/main" xmlns:p="http://schemas.openxmlformats.org/presentationml/2006/main" xmlns:r="http://schemas.openxmlformats.org/officeDocument/2006/relationships">
-  <p:cSld>
-    <p:spTree>
-      <p:nvGrpSpPr>
-        <p:cNvPr id="1" name=""/>
-        <p:cNvGrpSpPr/>
-        <p:nvPr/>
-      </p:nvGrpSpPr>
-      <p:grpSpPr/>
-      <p:sp>
-        <p:nvSpPr>
-          <p:cNvPr id="2" name="Rectangle 1"/>
-          <p:cNvSpPr/>
-          <p:nvPr/>
-        </p:nvSpPr>
-        <p:spPr>
-          <a:xfrm>
-            <a:off x="0" y="0"/>
-            <a:ext cx="12191695" cy="6858000"/>
-          </a:xfrm>
-          <a:prstGeom prst="rect">
-            <a:avLst/>
-          </a:prstGeom>
-          <a:solidFill>
-            <a:srgbClr val="F5F4EE"/>
-          </a:solidFill>
-          <a:ln>
-            <a:noFill/>
-          </a:ln>
-        </p:spPr>
-        <p:style>
-          <a:lnRef idx="1">
-            <a:schemeClr val="accent1"/>
-          </a:lnRef>
-          <a:fillRef idx="3">
-            <a:schemeClr val="accent1"/>
-          </a:fillRef>
-          <a:effectRef idx="2">
-            <a:schemeClr val="accent1"/>
-          </a:effectRef>
-          <a:fontRef idx="minor">
-            <a:schemeClr val="lt1"/>
-          </a:fontRef>
-        </p:style>
-        <p:txBody>
-          <a:bodyPr rtlCol="0" anchor="ctr"/>
-          <a:lstStyle/>
-          <a:p>
-            <a:pPr algn="ctr"/>
-          </a:p>
-        </p:txBody>
-      </p:sp>
-      <p:sp>
-        <p:nvSpPr>
-          <p:cNvPr id="3" name="Rectangle 2"/>
-          <p:cNvSpPr/>
-          <p:nvPr/>
-        </p:nvSpPr>
-        <p:spPr>
-          <a:xfrm>
-            <a:off x="0" y="0"/>
             <a:ext cx="320040" cy="6858000"/>
           </a:xfrm>
           <a:prstGeom prst="rect">
@@ -6690,8 +6666,8 @@
         </p:nvSpPr>
         <p:spPr>
           <a:xfrm>
-            <a:off x="640080" y="1463040"/>
-            <a:ext cx="10972800" cy="914400"/>
+            <a:off x="640080" y="411480"/>
+            <a:ext cx="10972800" cy="411480"/>
           </a:xfrm>
           <a:prstGeom prst="rect">
             <a:avLst/>
@@ -6706,9 +6682,9 @@
           <a:p>
             <a:pPr algn="l">
               <a:spcAft>
-                <a:spcPts val="600"/>
+                <a:spcPts val="500"/>
               </a:spcAft>
-              <a:defRPr sz="3200" b="1">
+              <a:defRPr sz="2400" b="1">
                 <a:solidFill>
                   <a:srgbClr val="0A0A0A"/>
                 </a:solidFill>
@@ -6716,7 +6692,7 @@
               </a:defRPr>
             </a:pPr>
             <a:r>
-              <a:t>Know what your AI will cost before you build.</a:t>
+              <a:t>8 · Future enhancements (not built yet)</a:t>
             </a:r>
           </a:p>
         </p:txBody>
@@ -6729,7 +6705,133 @@
         </p:nvSpPr>
         <p:spPr>
           <a:xfrm>
-            <a:off x="640080" y="2560320"/>
+            <a:off x="640080" y="1051560"/>
+            <a:ext cx="10972800" cy="1645920"/>
+          </a:xfrm>
+          <a:prstGeom prst="rect">
+            <a:avLst/>
+          </a:prstGeom>
+          <a:noFill/>
+        </p:spPr>
+        <p:txBody>
+          <a:bodyPr wrap="square">
+            <a:spAutoFit/>
+          </a:bodyPr>
+          <a:lstStyle/>
+          <a:p>
+            <a:pPr algn="l">
+              <a:spcAft>
+                <a:spcPts val="500"/>
+              </a:spcAft>
+              <a:defRPr sz="1700" b="0">
+                <a:solidFill>
+                  <a:srgbClr val="0A0A0A"/>
+                </a:solidFill>
+                <a:latin typeface="Arial"/>
+              </a:defRPr>
+            </a:pPr>
+            <a:r>
+              <a:t>• Human-review UI so recommended stacks can unlock</a:t>
+            </a:r>
+          </a:p>
+          <a:p>
+            <a:pPr algn="l">
+              <a:spcAft>
+                <a:spcPts val="500"/>
+              </a:spcAft>
+              <a:defRPr sz="1700" b="0">
+                <a:solidFill>
+                  <a:srgbClr val="0A0A0A"/>
+                </a:solidFill>
+                <a:latin typeface="Arial"/>
+              </a:defRPr>
+            </a:pPr>
+            <a:r>
+              <a:t>• Switch-point views after quality gates</a:t>
+            </a:r>
+          </a:p>
+          <a:p>
+            <a:pPr algn="l">
+              <a:spcAft>
+                <a:spcPts val="500"/>
+              </a:spcAft>
+              <a:defRPr sz="1700" b="0">
+                <a:solidFill>
+                  <a:srgbClr val="0A0A0A"/>
+                </a:solidFill>
+                <a:latin typeface="Arial"/>
+              </a:defRPr>
+            </a:pPr>
+            <a:r>
+              <a:t>• H-MEM decisions influencing a later run (next step in sponsor notes)</a:t>
+            </a:r>
+          </a:p>
+        </p:txBody>
+      </p:sp>
+      <p:sp>
+        <p:nvSpPr>
+          <p:cNvPr id="6" name="TextBox 5"/>
+          <p:cNvSpPr txBox="1"/>
+          <p:nvPr/>
+        </p:nvSpPr>
+        <p:spPr>
+          <a:xfrm>
+            <a:off x="640080" y="2926080"/>
+            <a:ext cx="10972800" cy="1280160"/>
+          </a:xfrm>
+          <a:prstGeom prst="rect">
+            <a:avLst/>
+          </a:prstGeom>
+          <a:noFill/>
+        </p:spPr>
+        <p:txBody>
+          <a:bodyPr wrap="square">
+            <a:spAutoFit/>
+          </a:bodyPr>
+          <a:lstStyle/>
+          <a:p>
+            <a:pPr algn="l">
+              <a:spcAft>
+                <a:spcPts val="500"/>
+              </a:spcAft>
+              <a:defRPr sz="1700" b="1">
+                <a:solidFill>
+                  <a:srgbClr val="0000FF"/>
+                </a:solidFill>
+                <a:latin typeface="Arial"/>
+              </a:defRPr>
+            </a:pPr>
+            <a:r>
+              <a:t>Repo: github.com/pradeepgnd/cost-optimizer</a:t>
+            </a:r>
+          </a:p>
+          <a:p>
+            <a:pPr algn="l">
+              <a:spcAft>
+                <a:spcPts val="500"/>
+              </a:spcAft>
+              <a:defRPr sz="1700" b="1">
+                <a:solidFill>
+                  <a:srgbClr val="0000FF"/>
+                </a:solidFill>
+                <a:latin typeface="Arial"/>
+              </a:defRPr>
+            </a:pPr>
+            <a:r>
+              <a:t>SAMPLE_MODE=true python run.py …   ·   python -m streamlit run streamlit_app.py</a:t>
+            </a:r>
+          </a:p>
+        </p:txBody>
+      </p:sp>
+      <p:sp>
+        <p:nvSpPr>
+          <p:cNvPr id="7" name="TextBox 6"/>
+          <p:cNvSpPr txBox="1"/>
+          <p:nvPr/>
+        </p:nvSpPr>
+        <p:spPr>
+          <a:xfrm>
+            <a:off x="640080" y="4480560"/>
             <a:ext cx="10972800" cy="1371600"/>
           </a:xfrm>
           <a:prstGeom prst="rect">
@@ -6745,9 +6847,9 @@
           <a:p>
             <a:pPr algn="l">
               <a:spcAft>
-                <a:spcPts val="600"/>
+                <a:spcPts val="500"/>
               </a:spcAft>
-              <a:defRPr sz="2000" b="0">
+              <a:defRPr sz="1500" b="0">
                 <a:solidFill>
                   <a:srgbClr val="3A3A3A"/>
                 </a:solidFill>
@@ -6761,9 +6863,9 @@
           <a:p>
             <a:pPr algn="l">
               <a:spcAft>
-                <a:spcPts val="600"/>
+                <a:spcPts val="500"/>
               </a:spcAft>
-              <a:defRPr sz="2000" b="0">
+              <a:defRPr sz="1500" b="0">
                 <a:solidFill>
                   <a:srgbClr val="3A3A3A"/>
                 </a:solidFill>
@@ -6771,101 +6873,23 @@
               </a:defRPr>
             </a:pPr>
             <a:r>
-              <a:t>Open source · sample mode works offline with no accounts</a:t>
-            </a:r>
-          </a:p>
-        </p:txBody>
-      </p:sp>
-      <p:sp>
-        <p:nvSpPr>
-          <p:cNvPr id="6" name="TextBox 5"/>
-          <p:cNvSpPr txBox="1"/>
-          <p:nvPr/>
-        </p:nvSpPr>
-        <p:spPr>
-          <a:xfrm>
-            <a:off x="640080" y="4206240"/>
-            <a:ext cx="10972800" cy="914400"/>
-          </a:xfrm>
-          <a:prstGeom prst="rect">
-            <a:avLst/>
-          </a:prstGeom>
-          <a:noFill/>
-        </p:spPr>
-        <p:txBody>
-          <a:bodyPr wrap="square">
-            <a:spAutoFit/>
-          </a:bodyPr>
-          <a:lstStyle/>
+              <a:t>Evidence-backed costs for Track 02 — agents that explain why, with a trace.</a:t>
+            </a:r>
+          </a:p>
           <a:p>
             <a:pPr algn="l">
               <a:spcAft>
-                <a:spcPts val="600"/>
+                <a:spcPts val="500"/>
               </a:spcAft>
-              <a:defRPr sz="1800" b="1">
-                <a:solidFill>
-                  <a:srgbClr val="0000FF"/>
+              <a:defRPr sz="1500" b="0">
+                <a:solidFill>
+                  <a:srgbClr val="3A3A3A"/>
                 </a:solidFill>
                 <a:latin typeface="Arial"/>
               </a:defRPr>
             </a:pPr>
             <a:r>
-              <a:t>github.com/pradeepgnd/cost-optimizer</a:t>
-            </a:r>
-          </a:p>
-          <a:p>
-            <a:pPr algn="l">
-              <a:spcAft>
-                <a:spcPts val="600"/>
-              </a:spcAft>
-              <a:defRPr sz="1800" b="1">
-                <a:solidFill>
-                  <a:srgbClr val="0000FF"/>
-                </a:solidFill>
-                <a:latin typeface="Arial"/>
-              </a:defRPr>
-            </a:pPr>
-            <a:r>
-              <a:t>python -m streamlit run streamlit_app.py</a:t>
-            </a:r>
-          </a:p>
-        </p:txBody>
-      </p:sp>
-      <p:sp>
-        <p:nvSpPr>
-          <p:cNvPr id="7" name="TextBox 6"/>
-          <p:cNvSpPr txBox="1"/>
-          <p:nvPr/>
-        </p:nvSpPr>
-        <p:spPr>
-          <a:xfrm>
-            <a:off x="640080" y="5852160"/>
-            <a:ext cx="10972800" cy="365760"/>
-          </a:xfrm>
-          <a:prstGeom prst="rect">
-            <a:avLst/>
-          </a:prstGeom>
-          <a:noFill/>
-        </p:spPr>
-        <p:txBody>
-          <a:bodyPr wrap="square">
-            <a:spAutoFit/>
-          </a:bodyPr>
-          <a:lstStyle/>
-          <a:p>
-            <a:pPr algn="l">
-              <a:spcAft>
-                <a:spcPts val="600"/>
-              </a:spcAft>
-              <a:defRPr sz="1200" b="0">
-                <a:solidFill>
-                  <a:srgbClr val="555555"/>
-                </a:solidFill>
-                <a:latin typeface="Arial"/>
-              </a:defRPr>
-            </a:pPr>
-            <a:r>
-              <a:t>Estimates and measurements — not financial advice. Unknown stays unknown.</a:t>
+              <a:t>Demo aim 2:30–3:30 · hard cap 4:00.</a:t>
             </a:r>
           </a:p>
         </p:txBody>

</xml_diff>